<commit_message>
Update Armenia LLM Summer School 2026 PowerPoint with requested changes
- Slide 2: Armenia alignment content (Firebird, Eleveight, YSU, 200 researchers by 2032)
- Slide 4: Pie chart (35 students, 42 industry), participant stats, countries
- Slide 7: Sponsor contribution details + collaborations highlights
- Slide 9: Financial aid data, budget breakdown (~15K travel, 11K logistics, 80 GPUs)
- Add update_pptx.py script and PPTX_UPDATE_README.md for logo instructions

Co-authored-by: armllm <armllm@users.noreply.github.com>
</commit_message>
<xml_diff>
--- a/2026/Armenia_LLM_Summer_School_2026 (2).pptx
+++ b/2026/Armenia_LLM_Summer_School_2026 (2).pptx
@@ -4963,7 +4963,7 @@
                 <a:cs typeface="Poppins"/>
                 <a:sym typeface="Poppins"/>
               </a:rPr>
-              <a:t>2026 CURRICULUM: BRIDGING THE GAP IN LLM RESEARCH</a:t>
+              <a:t>ALIGNMENT WITH ARMENIA'S AI DEVELOPMENT</a:t>
             </a:r>
             <a:endParaRPr sz="1602">
               <a:solidFill>
@@ -5122,7 +5122,7 @@
                 <a:cs typeface="Poppins"/>
                 <a:sym typeface="Poppins"/>
               </a:rPr>
-              <a:t>The summer school will offer a series of workshops, lectures, and hands-on sessions, aiming to bridge the knowledge gap among members of academia and industry in the fast-developing research area of foundational Large Language Models (LLMs).</a:t>
+              <a:t>This summer school is in line with current developments in Armenia: compute infrastructure by Firebird, Eleveight and YSU, and policies. Armenia aims to grow the number of strong world-class AI researchers by 2032 to reach 200. This school supports this goal by empowering existing researchers and students.</a:t>
             </a:r>
             <a:endParaRPr sz="1034">
               <a:solidFill>
@@ -7480,7 +7480,9 @@
                 <a:cs typeface="Poppins"/>
                 <a:sym typeface="Poppins"/>
               </a:rPr>
-              <a:t>Our track record demonstrates a significant and growing interest in high-level AI education within Armenia and the region. The summer school has become a competitive hub for talent training.</a:t>
+              <a:t>Our track record demonstrates a significant and growing interest in high-level AI education within Armenia and the region. The summer school has become a competitive hub for talent training.
+2025 Participation: 35 students (90% with financial aid), 42 industry professionals (paid 100,000 AMD). Participants from: Italy, USA, Russia, Iran, India, Armenia.
+2025 Participation: 35 students (90% with financial aid), 42 industry professionals (paid 100,000 AMD). Participants from: Italy, USA, Russia, Iran, India, Armenia.</a:t>
             </a:r>
             <a:endParaRPr sz="1034">
               <a:solidFill>
@@ -10795,1095 +10797,14 @@
 </p:sld>
 </file>
 
-<file path=ppt/slides/slide7.xml><?xml version="1.0" encoding="utf-8"?>
-<p:sld xmlns:a="http://schemas.openxmlformats.org/drawingml/2006/main" xmlns:r="http://schemas.openxmlformats.org/officeDocument/2006/relationships" xmlns:mc="http://schemas.openxmlformats.org/markup-compatibility/2006" xmlns:mv="urn:schemas-microsoft-com:mac:vml" xmlns:p="http://schemas.openxmlformats.org/presentationml/2006/main" xmlns:c="http://schemas.openxmlformats.org/drawingml/2006/chart" xmlns:dgm="http://schemas.openxmlformats.org/drawingml/2006/diagram" xmlns:o="urn:schemas-microsoft-com:office:office" xmlns:v="urn:schemas-microsoft-com:vml" xmlns:pvml="urn:schemas-microsoft-com:office:powerpoint" xmlns:com="http://schemas.openxmlformats.org/drawingml/2006/compatibility" xmlns:p14="http://schemas.microsoft.com/office/powerpoint/2010/main" xmlns:p15="http://schemas.microsoft.com/office/powerpoint/2012/main" xmlns:ahyp="http://schemas.microsoft.com/office/drawing/2018/hyperlinkcolor">
-  <p:cSld>
-    <p:spTree>
-      <p:nvGrpSpPr>
-        <p:cNvPr id="149" name="Shape 149"/>
-        <p:cNvGrpSpPr/>
-        <p:nvPr/>
-      </p:nvGrpSpPr>
-      <p:grpSpPr>
-        <a:xfrm>
-          <a:off x="0" y="0"/>
-          <a:ext cx="0" cy="0"/>
-          <a:chOff x="0" y="0"/>
-          <a:chExt cx="0" cy="0"/>
-        </a:xfrm>
-      </p:grpSpPr>
-      <p:pic>
-        <p:nvPicPr>
-          <p:cNvPr descr="preencoded.png" id="150" name="Google Shape;150;p7"/>
-          <p:cNvPicPr preferRelativeResize="0"/>
-          <p:nvPr/>
-        </p:nvPicPr>
-        <p:blipFill rotWithShape="1">
-          <a:blip r:embed="rId3">
-            <a:alphaModFix/>
-          </a:blip>
-          <a:srcRect b="0" l="0" r="0" t="0"/>
-          <a:stretch/>
-        </p:blipFill>
-        <p:spPr>
-          <a:xfrm>
-            <a:off x="0" y="977"/>
-            <a:ext cx="9144000" cy="5143500"/>
-          </a:xfrm>
-          <a:prstGeom prst="rect">
-            <a:avLst/>
-          </a:prstGeom>
-          <a:noFill/>
-          <a:ln>
-            <a:noFill/>
-          </a:ln>
-        </p:spPr>
-      </p:pic>
-      <p:sp>
-        <p:nvSpPr>
-          <p:cNvPr id="151" name="Google Shape;151;p7"/>
-          <p:cNvSpPr/>
-          <p:nvPr/>
-        </p:nvSpPr>
-        <p:spPr>
-          <a:xfrm>
-            <a:off x="2714625" y="1643063"/>
-            <a:ext cx="1571625" cy="857250"/>
-          </a:xfrm>
-          <a:prstGeom prst="rect">
-            <a:avLst/>
-          </a:prstGeom>
-          <a:solidFill>
-            <a:srgbClr val="F8FAFC"/>
-          </a:solidFill>
-          <a:ln>
-            <a:noFill/>
-          </a:ln>
-        </p:spPr>
-        <p:txBody>
-          <a:bodyPr anchorCtr="0" anchor="ctr" bIns="91425" lIns="91425" spcFirstLastPara="1" rIns="91425" wrap="square" tIns="91425">
-            <a:noAutofit/>
-          </a:bodyPr>
-          <a:lstStyle/>
-          <a:p>
-            <a:pPr indent="0" lvl="0" marL="0" rtl="0" algn="l">
-              <a:spcBef>
-                <a:spcPts val="0"/>
-              </a:spcBef>
-              <a:spcAft>
-                <a:spcPts val="0"/>
-              </a:spcAft>
-              <a:buNone/>
-            </a:pPr>
-            <a:r>
-              <a:t/>
-            </a:r>
-            <a:endParaRPr/>
-          </a:p>
-        </p:txBody>
-      </p:sp>
-      <p:sp>
-        <p:nvSpPr>
-          <p:cNvPr id="152" name="Google Shape;152;p7"/>
-          <p:cNvSpPr/>
-          <p:nvPr/>
-        </p:nvSpPr>
-        <p:spPr>
-          <a:xfrm>
-            <a:off x="428625" y="428625"/>
-            <a:ext cx="6658500" cy="281700"/>
-          </a:xfrm>
-          <a:prstGeom prst="rect">
-            <a:avLst/>
-          </a:prstGeom>
-          <a:noFill/>
-          <a:ln>
-            <a:noFill/>
-          </a:ln>
-        </p:spPr>
-        <p:txBody>
-          <a:bodyPr anchorCtr="0" anchor="t" bIns="0" lIns="0" spcFirstLastPara="1" rIns="0" wrap="square" tIns="0">
-            <a:spAutoFit/>
-          </a:bodyPr>
-          <a:lstStyle/>
-          <a:p>
-            <a:pPr indent="0" lvl="0" marL="0" marR="0" rtl="0" algn="l">
-              <a:lnSpc>
-                <a:spcPct val="137328"/>
-              </a:lnSpc>
-              <a:spcBef>
-                <a:spcPts val="0"/>
-              </a:spcBef>
-              <a:spcAft>
-                <a:spcPts val="0"/>
-              </a:spcAft>
-              <a:buClr>
-                <a:srgbClr val="0A192F"/>
-              </a:buClr>
-              <a:buSzPts val="1602"/>
-              <a:buFont typeface="Poppins"/>
-              <a:buNone/>
-            </a:pPr>
-            <a:r>
-              <a:rPr b="1" lang="en-US" sz="1602">
-                <a:solidFill>
-                  <a:srgbClr val="0A192F"/>
-                </a:solidFill>
-                <a:latin typeface="Poppins"/>
-                <a:ea typeface="Poppins"/>
-                <a:cs typeface="Poppins"/>
-                <a:sym typeface="Poppins"/>
-              </a:rPr>
-              <a:t>OUR PARTNERS AND SUPPORTERS OF PREVIOUS EDITIONS</a:t>
-            </a:r>
-            <a:endParaRPr sz="1602">
-              <a:solidFill>
-                <a:schemeClr val="dk1"/>
-              </a:solidFill>
-              <a:latin typeface="Calibri"/>
-              <a:ea typeface="Calibri"/>
-              <a:cs typeface="Calibri"/>
-              <a:sym typeface="Calibri"/>
-            </a:endParaRPr>
-          </a:p>
-        </p:txBody>
-      </p:sp>
-      <p:sp>
-        <p:nvSpPr>
-          <p:cNvPr id="153" name="Google Shape;153;p7"/>
-          <p:cNvSpPr/>
-          <p:nvPr/>
-        </p:nvSpPr>
-        <p:spPr>
-          <a:xfrm>
-            <a:off x="2714625" y="1643063"/>
-            <a:ext cx="1571625" cy="28575"/>
-          </a:xfrm>
-          <a:prstGeom prst="rect">
-            <a:avLst/>
-          </a:prstGeom>
-          <a:solidFill>
-            <a:srgbClr val="6B21A8"/>
-          </a:solidFill>
-          <a:ln>
-            <a:noFill/>
-          </a:ln>
-        </p:spPr>
-        <p:txBody>
-          <a:bodyPr anchorCtr="0" anchor="ctr" bIns="91425" lIns="91425" spcFirstLastPara="1" rIns="91425" wrap="square" tIns="91425">
-            <a:noAutofit/>
-          </a:bodyPr>
-          <a:lstStyle/>
-          <a:p>
-            <a:pPr indent="0" lvl="0" marL="0" rtl="0" algn="l">
-              <a:spcBef>
-                <a:spcPts val="0"/>
-              </a:spcBef>
-              <a:spcAft>
-                <a:spcPts val="0"/>
-              </a:spcAft>
-              <a:buNone/>
-            </a:pPr>
-            <a:r>
-              <a:t/>
-            </a:r>
-            <a:endParaRPr/>
-          </a:p>
-        </p:txBody>
-      </p:sp>
-      <p:sp>
-        <p:nvSpPr>
-          <p:cNvPr id="154" name="Google Shape;154;p7"/>
-          <p:cNvSpPr/>
-          <p:nvPr/>
-        </p:nvSpPr>
-        <p:spPr>
-          <a:xfrm>
-            <a:off x="0" y="4272855"/>
-            <a:ext cx="9144000" cy="884039"/>
-          </a:xfrm>
-          <a:prstGeom prst="rect">
-            <a:avLst/>
-          </a:prstGeom>
-          <a:noFill/>
-          <a:ln>
-            <a:noFill/>
-          </a:ln>
-        </p:spPr>
-        <p:txBody>
-          <a:bodyPr anchorCtr="0" anchor="t" bIns="510275" lIns="510275" spcFirstLastPara="1" rIns="510275" wrap="square" tIns="340225">
-            <a:spAutoFit/>
-          </a:bodyPr>
-          <a:lstStyle/>
-          <a:p>
-            <a:pPr indent="0" lvl="0" marL="0" marR="0" rtl="0" algn="ctr">
-              <a:lnSpc>
-                <a:spcPct val="131894"/>
-              </a:lnSpc>
-              <a:spcBef>
-                <a:spcPts val="0"/>
-              </a:spcBef>
-              <a:spcAft>
-                <a:spcPts val="0"/>
-              </a:spcAft>
-              <a:buClr>
-                <a:srgbClr val="334155"/>
-              </a:buClr>
-              <a:buSzPts val="834"/>
-              <a:buFont typeface="Poppins"/>
-              <a:buNone/>
-            </a:pPr>
-            <a:r>
-              <a:rPr lang="en-US" sz="1134">
-                <a:solidFill>
-                  <a:srgbClr val="334155"/>
-                </a:solidFill>
-                <a:latin typeface="Poppins"/>
-                <a:ea typeface="Poppins"/>
-                <a:cs typeface="Poppins"/>
-                <a:sym typeface="Poppins"/>
-              </a:rPr>
-              <a:t>We are grateful for the continued support of our partners in building Armenia's AI ecosystem.</a:t>
-            </a:r>
-            <a:endParaRPr sz="1134">
-              <a:solidFill>
-                <a:schemeClr val="dk1"/>
-              </a:solidFill>
-              <a:latin typeface="Calibri"/>
-              <a:ea typeface="Calibri"/>
-              <a:cs typeface="Calibri"/>
-              <a:sym typeface="Calibri"/>
-            </a:endParaRPr>
-          </a:p>
-        </p:txBody>
-      </p:sp>
-      <p:sp>
-        <p:nvSpPr>
-          <p:cNvPr id="155" name="Google Shape;155;p7"/>
-          <p:cNvSpPr/>
-          <p:nvPr/>
-        </p:nvSpPr>
-        <p:spPr>
-          <a:xfrm>
-            <a:off x="571500" y="1640384"/>
-            <a:ext cx="1571625" cy="857250"/>
-          </a:xfrm>
-          <a:prstGeom prst="rect">
-            <a:avLst/>
-          </a:prstGeom>
-          <a:solidFill>
-            <a:srgbClr val="F8FAFC"/>
-          </a:solidFill>
-          <a:ln>
-            <a:noFill/>
-          </a:ln>
-        </p:spPr>
-        <p:txBody>
-          <a:bodyPr anchorCtr="0" anchor="ctr" bIns="91425" lIns="91425" spcFirstLastPara="1" rIns="91425" wrap="square" tIns="91425">
-            <a:noAutofit/>
-          </a:bodyPr>
-          <a:lstStyle/>
-          <a:p>
-            <a:pPr indent="0" lvl="0" marL="0" rtl="0" algn="l">
-              <a:spcBef>
-                <a:spcPts val="0"/>
-              </a:spcBef>
-              <a:spcAft>
-                <a:spcPts val="0"/>
-              </a:spcAft>
-              <a:buNone/>
-            </a:pPr>
-            <a:r>
-              <a:t/>
-            </a:r>
-            <a:endParaRPr/>
-          </a:p>
-        </p:txBody>
-      </p:sp>
-      <p:sp>
-        <p:nvSpPr>
-          <p:cNvPr id="156" name="Google Shape;156;p7"/>
-          <p:cNvSpPr/>
-          <p:nvPr/>
-        </p:nvSpPr>
-        <p:spPr>
-          <a:xfrm>
-            <a:off x="571500" y="1640384"/>
-            <a:ext cx="1571625" cy="28575"/>
-          </a:xfrm>
-          <a:prstGeom prst="rect">
-            <a:avLst/>
-          </a:prstGeom>
-          <a:solidFill>
-            <a:srgbClr val="6B21A8"/>
-          </a:solidFill>
-          <a:ln>
-            <a:noFill/>
-          </a:ln>
-        </p:spPr>
-        <p:txBody>
-          <a:bodyPr anchorCtr="0" anchor="ctr" bIns="91425" lIns="91425" spcFirstLastPara="1" rIns="91425" wrap="square" tIns="91425">
-            <a:noAutofit/>
-          </a:bodyPr>
-          <a:lstStyle/>
-          <a:p>
-            <a:pPr indent="0" lvl="0" marL="0" rtl="0" algn="l">
-              <a:spcBef>
-                <a:spcPts val="0"/>
-              </a:spcBef>
-              <a:spcAft>
-                <a:spcPts val="0"/>
-              </a:spcAft>
-              <a:buNone/>
-            </a:pPr>
-            <a:r>
-              <a:t/>
-            </a:r>
-            <a:endParaRPr/>
-          </a:p>
-        </p:txBody>
-      </p:sp>
-      <p:sp>
-        <p:nvSpPr>
-          <p:cNvPr id="157" name="Google Shape;157;p7"/>
-          <p:cNvSpPr/>
-          <p:nvPr/>
-        </p:nvSpPr>
-        <p:spPr>
-          <a:xfrm>
-            <a:off x="4857750" y="1640384"/>
-            <a:ext cx="1571625" cy="857250"/>
-          </a:xfrm>
-          <a:prstGeom prst="rect">
-            <a:avLst/>
-          </a:prstGeom>
-          <a:solidFill>
-            <a:srgbClr val="F8FAFC"/>
-          </a:solidFill>
-          <a:ln>
-            <a:noFill/>
-          </a:ln>
-        </p:spPr>
-        <p:txBody>
-          <a:bodyPr anchorCtr="0" anchor="ctr" bIns="91425" lIns="91425" spcFirstLastPara="1" rIns="91425" wrap="square" tIns="91425">
-            <a:noAutofit/>
-          </a:bodyPr>
-          <a:lstStyle/>
-          <a:p>
-            <a:pPr indent="0" lvl="0" marL="0" rtl="0" algn="l">
-              <a:spcBef>
-                <a:spcPts val="0"/>
-              </a:spcBef>
-              <a:spcAft>
-                <a:spcPts val="0"/>
-              </a:spcAft>
-              <a:buNone/>
-            </a:pPr>
-            <a:r>
-              <a:t/>
-            </a:r>
-            <a:endParaRPr/>
-          </a:p>
-        </p:txBody>
-      </p:sp>
-      <p:sp>
-        <p:nvSpPr>
-          <p:cNvPr id="158" name="Google Shape;158;p7"/>
-          <p:cNvSpPr/>
-          <p:nvPr/>
-        </p:nvSpPr>
-        <p:spPr>
-          <a:xfrm>
-            <a:off x="4857750" y="1640384"/>
-            <a:ext cx="1571625" cy="28575"/>
-          </a:xfrm>
-          <a:prstGeom prst="rect">
-            <a:avLst/>
-          </a:prstGeom>
-          <a:solidFill>
-            <a:srgbClr val="6B21A8"/>
-          </a:solidFill>
-          <a:ln>
-            <a:noFill/>
-          </a:ln>
-        </p:spPr>
-        <p:txBody>
-          <a:bodyPr anchorCtr="0" anchor="ctr" bIns="91425" lIns="91425" spcFirstLastPara="1" rIns="91425" wrap="square" tIns="91425">
-            <a:noAutofit/>
-          </a:bodyPr>
-          <a:lstStyle/>
-          <a:p>
-            <a:pPr indent="0" lvl="0" marL="0" rtl="0" algn="l">
-              <a:spcBef>
-                <a:spcPts val="0"/>
-              </a:spcBef>
-              <a:spcAft>
-                <a:spcPts val="0"/>
-              </a:spcAft>
-              <a:buNone/>
-            </a:pPr>
-            <a:r>
-              <a:t/>
-            </a:r>
-            <a:endParaRPr/>
-          </a:p>
-        </p:txBody>
-      </p:sp>
-      <p:sp>
-        <p:nvSpPr>
-          <p:cNvPr id="159" name="Google Shape;159;p7"/>
-          <p:cNvSpPr/>
-          <p:nvPr/>
-        </p:nvSpPr>
-        <p:spPr>
-          <a:xfrm>
-            <a:off x="7000875" y="1640384"/>
-            <a:ext cx="1571625" cy="857250"/>
-          </a:xfrm>
-          <a:prstGeom prst="rect">
-            <a:avLst/>
-          </a:prstGeom>
-          <a:solidFill>
-            <a:srgbClr val="F8FAFC"/>
-          </a:solidFill>
-          <a:ln>
-            <a:noFill/>
-          </a:ln>
-        </p:spPr>
-        <p:txBody>
-          <a:bodyPr anchorCtr="0" anchor="ctr" bIns="91425" lIns="91425" spcFirstLastPara="1" rIns="91425" wrap="square" tIns="91425">
-            <a:noAutofit/>
-          </a:bodyPr>
-          <a:lstStyle/>
-          <a:p>
-            <a:pPr indent="0" lvl="0" marL="0" rtl="0" algn="l">
-              <a:spcBef>
-                <a:spcPts val="0"/>
-              </a:spcBef>
-              <a:spcAft>
-                <a:spcPts val="0"/>
-              </a:spcAft>
-              <a:buNone/>
-            </a:pPr>
-            <a:r>
-              <a:t/>
-            </a:r>
-            <a:endParaRPr/>
-          </a:p>
-        </p:txBody>
-      </p:sp>
-      <p:sp>
-        <p:nvSpPr>
-          <p:cNvPr id="160" name="Google Shape;160;p7"/>
-          <p:cNvSpPr/>
-          <p:nvPr/>
-        </p:nvSpPr>
-        <p:spPr>
-          <a:xfrm>
-            <a:off x="7000875" y="1640384"/>
-            <a:ext cx="1571625" cy="28575"/>
-          </a:xfrm>
-          <a:prstGeom prst="rect">
-            <a:avLst/>
-          </a:prstGeom>
-          <a:solidFill>
-            <a:srgbClr val="6B21A8"/>
-          </a:solidFill>
-          <a:ln>
-            <a:noFill/>
-          </a:ln>
-        </p:spPr>
-        <p:txBody>
-          <a:bodyPr anchorCtr="0" anchor="ctr" bIns="91425" lIns="91425" spcFirstLastPara="1" rIns="91425" wrap="square" tIns="91425">
-            <a:noAutofit/>
-          </a:bodyPr>
-          <a:lstStyle/>
-          <a:p>
-            <a:pPr indent="0" lvl="0" marL="0" rtl="0" algn="l">
-              <a:spcBef>
-                <a:spcPts val="0"/>
-              </a:spcBef>
-              <a:spcAft>
-                <a:spcPts val="0"/>
-              </a:spcAft>
-              <a:buNone/>
-            </a:pPr>
-            <a:r>
-              <a:t/>
-            </a:r>
-            <a:endParaRPr/>
-          </a:p>
-        </p:txBody>
-      </p:sp>
-      <p:sp>
-        <p:nvSpPr>
-          <p:cNvPr id="161" name="Google Shape;161;p7"/>
-          <p:cNvSpPr/>
-          <p:nvPr/>
-        </p:nvSpPr>
-        <p:spPr>
-          <a:xfrm>
-            <a:off x="2714625" y="3007965"/>
-            <a:ext cx="1571625" cy="857250"/>
-          </a:xfrm>
-          <a:prstGeom prst="rect">
-            <a:avLst/>
-          </a:prstGeom>
-          <a:solidFill>
-            <a:srgbClr val="F8FAFC"/>
-          </a:solidFill>
-          <a:ln>
-            <a:noFill/>
-          </a:ln>
-        </p:spPr>
-        <p:txBody>
-          <a:bodyPr anchorCtr="0" anchor="ctr" bIns="91425" lIns="91425" spcFirstLastPara="1" rIns="91425" wrap="square" tIns="91425">
-            <a:noAutofit/>
-          </a:bodyPr>
-          <a:lstStyle/>
-          <a:p>
-            <a:pPr indent="0" lvl="0" marL="0" rtl="0" algn="l">
-              <a:spcBef>
-                <a:spcPts val="0"/>
-              </a:spcBef>
-              <a:spcAft>
-                <a:spcPts val="0"/>
-              </a:spcAft>
-              <a:buNone/>
-            </a:pPr>
-            <a:r>
-              <a:t/>
-            </a:r>
-            <a:endParaRPr/>
-          </a:p>
-        </p:txBody>
-      </p:sp>
-      <p:sp>
-        <p:nvSpPr>
-          <p:cNvPr id="162" name="Google Shape;162;p7"/>
-          <p:cNvSpPr/>
-          <p:nvPr/>
-        </p:nvSpPr>
-        <p:spPr>
-          <a:xfrm>
-            <a:off x="2714625" y="3007965"/>
-            <a:ext cx="1571625" cy="28575"/>
-          </a:xfrm>
-          <a:prstGeom prst="rect">
-            <a:avLst/>
-          </a:prstGeom>
-          <a:solidFill>
-            <a:srgbClr val="6B21A8"/>
-          </a:solidFill>
-          <a:ln>
-            <a:noFill/>
-          </a:ln>
-        </p:spPr>
-        <p:txBody>
-          <a:bodyPr anchorCtr="0" anchor="ctr" bIns="91425" lIns="91425" spcFirstLastPara="1" rIns="91425" wrap="square" tIns="91425">
-            <a:noAutofit/>
-          </a:bodyPr>
-          <a:lstStyle/>
-          <a:p>
-            <a:pPr indent="0" lvl="0" marL="0" rtl="0" algn="l">
-              <a:spcBef>
-                <a:spcPts val="0"/>
-              </a:spcBef>
-              <a:spcAft>
-                <a:spcPts val="0"/>
-              </a:spcAft>
-              <a:buNone/>
-            </a:pPr>
-            <a:r>
-              <a:t/>
-            </a:r>
-            <a:endParaRPr/>
-          </a:p>
-        </p:txBody>
-      </p:sp>
-      <p:sp>
-        <p:nvSpPr>
-          <p:cNvPr id="163" name="Google Shape;163;p7"/>
-          <p:cNvSpPr/>
-          <p:nvPr/>
-        </p:nvSpPr>
-        <p:spPr>
-          <a:xfrm>
-            <a:off x="571500" y="3005286"/>
-            <a:ext cx="1571625" cy="857250"/>
-          </a:xfrm>
-          <a:prstGeom prst="rect">
-            <a:avLst/>
-          </a:prstGeom>
-          <a:solidFill>
-            <a:srgbClr val="F8FAFC"/>
-          </a:solidFill>
-          <a:ln>
-            <a:noFill/>
-          </a:ln>
-        </p:spPr>
-        <p:txBody>
-          <a:bodyPr anchorCtr="0" anchor="ctr" bIns="91425" lIns="91425" spcFirstLastPara="1" rIns="91425" wrap="square" tIns="91425">
-            <a:noAutofit/>
-          </a:bodyPr>
-          <a:lstStyle/>
-          <a:p>
-            <a:pPr indent="0" lvl="0" marL="0" rtl="0" algn="l">
-              <a:spcBef>
-                <a:spcPts val="0"/>
-              </a:spcBef>
-              <a:spcAft>
-                <a:spcPts val="0"/>
-              </a:spcAft>
-              <a:buNone/>
-            </a:pPr>
-            <a:r>
-              <a:t/>
-            </a:r>
-            <a:endParaRPr/>
-          </a:p>
-        </p:txBody>
-      </p:sp>
-      <p:sp>
-        <p:nvSpPr>
-          <p:cNvPr id="164" name="Google Shape;164;p7"/>
-          <p:cNvSpPr/>
-          <p:nvPr/>
-        </p:nvSpPr>
-        <p:spPr>
-          <a:xfrm>
-            <a:off x="571500" y="3005286"/>
-            <a:ext cx="1571625" cy="28575"/>
-          </a:xfrm>
-          <a:prstGeom prst="rect">
-            <a:avLst/>
-          </a:prstGeom>
-          <a:solidFill>
-            <a:srgbClr val="6B21A8"/>
-          </a:solidFill>
-          <a:ln>
-            <a:noFill/>
-          </a:ln>
-        </p:spPr>
-        <p:txBody>
-          <a:bodyPr anchorCtr="0" anchor="ctr" bIns="91425" lIns="91425" spcFirstLastPara="1" rIns="91425" wrap="square" tIns="91425">
-            <a:noAutofit/>
-          </a:bodyPr>
-          <a:lstStyle/>
-          <a:p>
-            <a:pPr indent="0" lvl="0" marL="0" rtl="0" algn="l">
-              <a:spcBef>
-                <a:spcPts val="0"/>
-              </a:spcBef>
-              <a:spcAft>
-                <a:spcPts val="0"/>
-              </a:spcAft>
-              <a:buNone/>
-            </a:pPr>
-            <a:r>
-              <a:t/>
-            </a:r>
-            <a:endParaRPr/>
-          </a:p>
-        </p:txBody>
-      </p:sp>
-      <p:sp>
-        <p:nvSpPr>
-          <p:cNvPr id="165" name="Google Shape;165;p7"/>
-          <p:cNvSpPr/>
-          <p:nvPr/>
-        </p:nvSpPr>
-        <p:spPr>
-          <a:xfrm>
-            <a:off x="4857750" y="3005286"/>
-            <a:ext cx="1571625" cy="857250"/>
-          </a:xfrm>
-          <a:prstGeom prst="rect">
-            <a:avLst/>
-          </a:prstGeom>
-          <a:solidFill>
-            <a:srgbClr val="F8FAFC"/>
-          </a:solidFill>
-          <a:ln>
-            <a:noFill/>
-          </a:ln>
-        </p:spPr>
-        <p:txBody>
-          <a:bodyPr anchorCtr="0" anchor="ctr" bIns="91425" lIns="91425" spcFirstLastPara="1" rIns="91425" wrap="square" tIns="91425">
-            <a:noAutofit/>
-          </a:bodyPr>
-          <a:lstStyle/>
-          <a:p>
-            <a:pPr indent="0" lvl="0" marL="0" rtl="0" algn="l">
-              <a:spcBef>
-                <a:spcPts val="0"/>
-              </a:spcBef>
-              <a:spcAft>
-                <a:spcPts val="0"/>
-              </a:spcAft>
-              <a:buNone/>
-            </a:pPr>
-            <a:r>
-              <a:t/>
-            </a:r>
-            <a:endParaRPr/>
-          </a:p>
-        </p:txBody>
-      </p:sp>
-      <p:sp>
-        <p:nvSpPr>
-          <p:cNvPr id="166" name="Google Shape;166;p7"/>
-          <p:cNvSpPr/>
-          <p:nvPr/>
-        </p:nvSpPr>
-        <p:spPr>
-          <a:xfrm>
-            <a:off x="4857750" y="3005286"/>
-            <a:ext cx="1571625" cy="28575"/>
-          </a:xfrm>
-          <a:prstGeom prst="rect">
-            <a:avLst/>
-          </a:prstGeom>
-          <a:solidFill>
-            <a:srgbClr val="6B21A8"/>
-          </a:solidFill>
-          <a:ln>
-            <a:noFill/>
-          </a:ln>
-        </p:spPr>
-        <p:txBody>
-          <a:bodyPr anchorCtr="0" anchor="ctr" bIns="91425" lIns="91425" spcFirstLastPara="1" rIns="91425" wrap="square" tIns="91425">
-            <a:noAutofit/>
-          </a:bodyPr>
-          <a:lstStyle/>
-          <a:p>
-            <a:pPr indent="0" lvl="0" marL="0" rtl="0" algn="l">
-              <a:spcBef>
-                <a:spcPts val="0"/>
-              </a:spcBef>
-              <a:spcAft>
-                <a:spcPts val="0"/>
-              </a:spcAft>
-              <a:buNone/>
-            </a:pPr>
-            <a:r>
-              <a:t/>
-            </a:r>
-            <a:endParaRPr/>
-          </a:p>
-        </p:txBody>
-      </p:sp>
-      <p:sp>
-        <p:nvSpPr>
-          <p:cNvPr id="167" name="Google Shape;167;p7"/>
-          <p:cNvSpPr/>
-          <p:nvPr/>
-        </p:nvSpPr>
-        <p:spPr>
-          <a:xfrm>
-            <a:off x="7000875" y="3005286"/>
-            <a:ext cx="1571625" cy="857250"/>
-          </a:xfrm>
-          <a:prstGeom prst="rect">
-            <a:avLst/>
-          </a:prstGeom>
-          <a:solidFill>
-            <a:srgbClr val="F8FAFC"/>
-          </a:solidFill>
-          <a:ln>
-            <a:noFill/>
-          </a:ln>
-        </p:spPr>
-        <p:txBody>
-          <a:bodyPr anchorCtr="0" anchor="ctr" bIns="91425" lIns="91425" spcFirstLastPara="1" rIns="91425" wrap="square" tIns="91425">
-            <a:noAutofit/>
-          </a:bodyPr>
-          <a:lstStyle/>
-          <a:p>
-            <a:pPr indent="0" lvl="0" marL="0" rtl="0" algn="l">
-              <a:spcBef>
-                <a:spcPts val="0"/>
-              </a:spcBef>
-              <a:spcAft>
-                <a:spcPts val="0"/>
-              </a:spcAft>
-              <a:buNone/>
-            </a:pPr>
-            <a:r>
-              <a:t/>
-            </a:r>
-            <a:endParaRPr/>
-          </a:p>
-        </p:txBody>
-      </p:sp>
-      <p:sp>
-        <p:nvSpPr>
-          <p:cNvPr id="168" name="Google Shape;168;p7"/>
-          <p:cNvSpPr/>
-          <p:nvPr/>
-        </p:nvSpPr>
-        <p:spPr>
-          <a:xfrm>
-            <a:off x="7000875" y="3005286"/>
-            <a:ext cx="1571625" cy="28575"/>
-          </a:xfrm>
-          <a:prstGeom prst="rect">
-            <a:avLst/>
-          </a:prstGeom>
-          <a:solidFill>
-            <a:srgbClr val="6B21A8"/>
-          </a:solidFill>
-          <a:ln>
-            <a:noFill/>
-          </a:ln>
-        </p:spPr>
-        <p:txBody>
-          <a:bodyPr anchorCtr="0" anchor="ctr" bIns="91425" lIns="91425" spcFirstLastPara="1" rIns="91425" wrap="square" tIns="91425">
-            <a:noAutofit/>
-          </a:bodyPr>
-          <a:lstStyle/>
-          <a:p>
-            <a:pPr indent="0" lvl="0" marL="0" rtl="0" algn="l">
-              <a:spcBef>
-                <a:spcPts val="0"/>
-              </a:spcBef>
-              <a:spcAft>
-                <a:spcPts val="0"/>
-              </a:spcAft>
-              <a:buNone/>
-            </a:pPr>
-            <a:r>
-              <a:t/>
-            </a:r>
-            <a:endParaRPr/>
-          </a:p>
-        </p:txBody>
-      </p:sp>
-      <p:pic>
-        <p:nvPicPr>
-          <p:cNvPr id="169" name="Google Shape;169;p7"/>
-          <p:cNvPicPr preferRelativeResize="0"/>
-          <p:nvPr/>
-        </p:nvPicPr>
-        <p:blipFill rotWithShape="1">
-          <a:blip r:embed="rId4">
-            <a:alphaModFix/>
-          </a:blip>
-          <a:srcRect b="0" l="0" r="0" t="0"/>
-          <a:stretch/>
-        </p:blipFill>
-        <p:spPr>
-          <a:xfrm>
-            <a:off x="734511" y="3307333"/>
-            <a:ext cx="1206387" cy="281731"/>
-          </a:xfrm>
-          <a:prstGeom prst="rect">
-            <a:avLst/>
-          </a:prstGeom>
-          <a:noFill/>
-          <a:ln>
-            <a:noFill/>
-          </a:ln>
-        </p:spPr>
-      </p:pic>
-      <p:pic>
-        <p:nvPicPr>
-          <p:cNvPr id="170" name="Google Shape;170;p7"/>
-          <p:cNvPicPr preferRelativeResize="0"/>
-          <p:nvPr/>
-        </p:nvPicPr>
-        <p:blipFill rotWithShape="1">
-          <a:blip r:embed="rId5">
-            <a:alphaModFix/>
-          </a:blip>
-          <a:srcRect b="0" l="0" r="0" t="0"/>
-          <a:stretch/>
-        </p:blipFill>
-        <p:spPr>
-          <a:xfrm>
-            <a:off x="7341942" y="3239247"/>
-            <a:ext cx="889489" cy="417902"/>
-          </a:xfrm>
-          <a:prstGeom prst="rect">
-            <a:avLst/>
-          </a:prstGeom>
-          <a:noFill/>
-          <a:ln>
-            <a:noFill/>
-          </a:ln>
-        </p:spPr>
-      </p:pic>
-      <p:pic>
-        <p:nvPicPr>
-          <p:cNvPr id="171" name="Google Shape;171;p7"/>
-          <p:cNvPicPr preferRelativeResize="0"/>
-          <p:nvPr/>
-        </p:nvPicPr>
-        <p:blipFill rotWithShape="1">
-          <a:blip r:embed="rId6">
-            <a:alphaModFix/>
-          </a:blip>
-          <a:srcRect b="0" l="0" r="0" t="0"/>
-          <a:stretch/>
-        </p:blipFill>
-        <p:spPr>
-          <a:xfrm>
-            <a:off x="2854892" y="3339172"/>
-            <a:ext cx="1291090" cy="194837"/>
-          </a:xfrm>
-          <a:prstGeom prst="rect">
-            <a:avLst/>
-          </a:prstGeom>
-          <a:noFill/>
-          <a:ln>
-            <a:noFill/>
-          </a:ln>
-        </p:spPr>
-      </p:pic>
-      <p:pic>
-        <p:nvPicPr>
-          <p:cNvPr id="172" name="Google Shape;172;p7"/>
-          <p:cNvPicPr preferRelativeResize="0"/>
-          <p:nvPr/>
-        </p:nvPicPr>
-        <p:blipFill rotWithShape="1">
-          <a:blip r:embed="rId7">
-            <a:alphaModFix/>
-          </a:blip>
-          <a:srcRect b="0" l="0" r="0" t="0"/>
-          <a:stretch/>
-        </p:blipFill>
-        <p:spPr>
-          <a:xfrm>
-            <a:off x="895683" y="1613891"/>
-            <a:ext cx="878384" cy="878384"/>
-          </a:xfrm>
-          <a:prstGeom prst="rect">
-            <a:avLst/>
-          </a:prstGeom>
-          <a:noFill/>
-          <a:ln>
-            <a:noFill/>
-          </a:ln>
-        </p:spPr>
-      </p:pic>
-      <p:pic>
-        <p:nvPicPr>
-          <p:cNvPr id="173" name="Google Shape;173;p7"/>
-          <p:cNvPicPr preferRelativeResize="0"/>
-          <p:nvPr/>
-        </p:nvPicPr>
-        <p:blipFill rotWithShape="1">
-          <a:blip r:embed="rId8">
-            <a:alphaModFix/>
-          </a:blip>
-          <a:srcRect b="0" l="0" r="0" t="0"/>
-          <a:stretch/>
-        </p:blipFill>
-        <p:spPr>
-          <a:xfrm>
-            <a:off x="4947840" y="1893060"/>
-            <a:ext cx="1391445" cy="380473"/>
-          </a:xfrm>
-          <a:prstGeom prst="rect">
-            <a:avLst/>
-          </a:prstGeom>
-          <a:noFill/>
-          <a:ln>
-            <a:noFill/>
-          </a:ln>
-        </p:spPr>
-      </p:pic>
-      <p:pic>
-        <p:nvPicPr>
-          <p:cNvPr id="174" name="Google Shape;174;p7"/>
-          <p:cNvPicPr preferRelativeResize="0"/>
-          <p:nvPr/>
-        </p:nvPicPr>
-        <p:blipFill rotWithShape="1">
-          <a:blip r:embed="rId9">
-            <a:alphaModFix/>
-          </a:blip>
-          <a:srcRect b="0" l="0" r="0" t="0"/>
-          <a:stretch/>
-        </p:blipFill>
-        <p:spPr>
-          <a:xfrm>
-            <a:off x="7435621" y="1717944"/>
-            <a:ext cx="702129" cy="702129"/>
-          </a:xfrm>
-          <a:prstGeom prst="rect">
-            <a:avLst/>
-          </a:prstGeom>
-          <a:noFill/>
-          <a:ln>
-            <a:noFill/>
-          </a:ln>
-        </p:spPr>
-      </p:pic>
-      <p:pic>
-        <p:nvPicPr>
-          <p:cNvPr id="175" name="Google Shape;175;p7"/>
-          <p:cNvPicPr preferRelativeResize="0"/>
-          <p:nvPr/>
-        </p:nvPicPr>
-        <p:blipFill rotWithShape="1">
-          <a:blip r:embed="rId10">
-            <a:alphaModFix/>
-          </a:blip>
-          <a:srcRect b="0" l="0" r="0" t="0"/>
-          <a:stretch/>
-        </p:blipFill>
-        <p:spPr>
-          <a:xfrm>
-            <a:off x="5307805" y="3111771"/>
-            <a:ext cx="671514" cy="671514"/>
-          </a:xfrm>
-          <a:prstGeom prst="rect">
-            <a:avLst/>
-          </a:prstGeom>
-          <a:noFill/>
-          <a:ln>
-            <a:noFill/>
-          </a:ln>
-        </p:spPr>
-      </p:pic>
-      <p:pic>
-        <p:nvPicPr>
-          <p:cNvPr id="176" name="Google Shape;176;p7" title="67d25f39a9af6b056066b8ae_ARCS-ai logo-p-800.png"/>
-          <p:cNvPicPr preferRelativeResize="0"/>
-          <p:nvPr/>
-        </p:nvPicPr>
-        <p:blipFill>
-          <a:blip r:embed="rId11">
-            <a:alphaModFix/>
-          </a:blip>
-          <a:stretch>
-            <a:fillRect/>
-          </a:stretch>
-        </p:blipFill>
-        <p:spPr>
-          <a:xfrm>
-            <a:off x="3134350" y="1717200"/>
-            <a:ext cx="732176" cy="732176"/>
-          </a:xfrm>
-          <a:prstGeom prst="rect">
-            <a:avLst/>
-          </a:prstGeom>
-          <a:solidFill>
-            <a:srgbClr val="F8FAFC"/>
-          </a:solidFill>
-          <a:ln>
-            <a:noFill/>
-          </a:ln>
-        </p:spPr>
-      </p:pic>
-    </p:spTree>
-  </p:cSld>
-  <p:clrMapOvr>
-    <a:masterClrMapping/>
-  </p:clrMapOvr>
-</p:sld>
+<file path=ppt/slides/slide7.xml><?xml version="1.0" encoding="UTF-8" standalone="yes"?>
+<p:sld xmlns:a="http://schemas.openxmlformats.org/drawingml/2006/main" xmlns:r="http://schemas.openxmlformats.org/officeDocument/2006/relationships" xmlns:mc="http://schemas.openxmlformats.org/markup-compatibility/2006" xmlns:mv="urn:schemas-microsoft-com:mac:vml" xmlns:p="http://schemas.openxmlformats.org/presentationml/2006/main" xmlns:c="http://schemas.openxmlformats.org/drawingml/2006/chart" xmlns:dgm="http://schemas.openxmlformats.org/drawingml/2006/diagram" xmlns:o="urn:schemas-microsoft-com:office:office" xmlns:v="urn:schemas-microsoft-com:vml" xmlns:pvml="urn:schemas-microsoft-com:office:powerpoint" xmlns:com="http://schemas.openxmlformats.org/drawingml/2006/compatibility" xmlns:p14="http://schemas.microsoft.com/office/powerpoint/2010/main" xmlns:p15="http://schemas.microsoft.com/office/powerpoint/2012/main" xmlns:ahyp="http://schemas.microsoft.com/office/drawing/2018/hyperlinkcolor"><p:cSld><p:spTree><p:nvGrpSpPr><p:cNvPr id="149" name="Shape 149"/><p:cNvGrpSpPr/><p:nvPr/></p:nvGrpSpPr><p:grpSpPr><a:xfrm><a:off x="0" y="0"/><a:ext cx="0" cy="0"/><a:chOff x="0" y="0"/><a:chExt cx="0" cy="0"/></a:xfrm></p:grpSpPr><p:pic><p:nvPicPr><p:cNvPr descr="preencoded.png" id="150" name="Google Shape;150;p7"/><p:cNvPicPr preferRelativeResize="0"/><p:nvPr/></p:nvPicPr><p:blipFill rotWithShape="1"><a:blip r:embed="rId3"><a:alphaModFix/></a:blip><a:srcRect b="0" l="0" r="0" t="0"/><a:stretch/></p:blipFill><p:spPr><a:xfrm><a:off x="0" y="977"/><a:ext cx="9144000" cy="5143500"/></a:xfrm><a:prstGeom prst="rect"><a:avLst/></a:prstGeom><a:noFill/><a:ln><a:noFill/></a:ln></p:spPr></p:pic><p:sp><p:nvSpPr><p:cNvPr id="151" name="Google Shape;151;p7"/><p:cNvSpPr/><p:nvPr/></p:nvSpPr><p:spPr><a:xfrm><a:off x="2714625" y="1643063"/><a:ext cx="1571625" cy="857250"/></a:xfrm><a:prstGeom prst="rect"><a:avLst/></a:prstGeom><a:solidFill><a:srgbClr val="F8FAFC"/></a:solidFill><a:ln><a:noFill/></a:ln></p:spPr><p:txBody><a:bodyPr anchorCtr="0" anchor="ctr" bIns="91425" lIns="91425" spcFirstLastPara="1" rIns="91425" wrap="square" tIns="91425"><a:noAutofit/></a:bodyPr><a:lstStyle/><a:p><a:pPr indent="0" lvl="0" marL="0" rtl="0" algn="l"><a:spcBef><a:spcPts val="0"/></a:spcBef><a:spcAft><a:spcPts val="0"/></a:spcAft><a:buNone/></a:pPr><a:r><a:t></a:t></a:r><a:endParaRPr/></a:p></p:txBody></p:sp><p:sp><p:nvSpPr><p:cNvPr id="152" name="Google Shape;152;p7"/><p:cNvSpPr/><p:nvPr/></p:nvSpPr><p:spPr><a:xfrm><a:off x="428625" y="428625"/><a:ext cx="6658500" cy="281700"/></a:xfrm><a:prstGeom prst="rect"><a:avLst/></a:prstGeom><a:noFill/><a:ln><a:noFill/></a:ln></p:spPr><p:txBody><a:bodyPr anchorCtr="0" anchor="t" bIns="0" lIns="0" spcFirstLastPara="1" rIns="0" wrap="square" tIns="0"><a:spAutoFit/></a:bodyPr><a:lstStyle/><a:p><a:pPr indent="0" lvl="0" marL="0" marR="0" rtl="0" algn="l"><a:lnSpc><a:spcPct val="137328"/></a:lnSpc><a:spcBef><a:spcPts val="0"/></a:spcBef><a:spcAft><a:spcPts val="0"/></a:spcAft><a:buClr><a:srgbClr val="0A192F"/></a:buClr><a:buSzPts val="1602"/><a:buFont typeface="Poppins"/><a:buNone/></a:pPr><a:r><a:rPr b="1" lang="en-US" sz="1602"><a:solidFill><a:srgbClr val="0A192F"/></a:solidFill><a:latin typeface="Poppins"/><a:ea typeface="Poppins"/><a:cs typeface="Poppins"/><a:sym typeface="Poppins"/></a:rPr><a:t>OUR PARTNERS AND SUPPORTERS OF PREVIOUS EDITIONS</a:t></a:r><a:endParaRPr sz="1602"><a:solidFill><a:schemeClr val="dk1"/></a:solidFill><a:latin typeface="Calibri"/><a:ea typeface="Calibri"/><a:cs typeface="Calibri"/><a:sym typeface="Calibri"/></a:endParaRPr></a:p></p:txBody></p:sp><p:sp><p:nvSpPr><p:cNvPr id="153" name="Google Shape;153;p7"/><p:cNvSpPr/><p:nvPr/></p:nvSpPr><p:spPr><a:xfrm><a:off x="2714625" y="1643063"/><a:ext cx="1571625" cy="28575"/></a:xfrm><a:prstGeom prst="rect"><a:avLst/></a:prstGeom><a:solidFill><a:srgbClr val="6B21A8"/></a:solidFill><a:ln><a:noFill/></a:ln></p:spPr><p:txBody><a:bodyPr anchorCtr="0" anchor="ctr" bIns="91425" lIns="91425" spcFirstLastPara="1" rIns="91425" wrap="square" tIns="91425"><a:noAutofit/></a:bodyPr><a:lstStyle/><a:p><a:pPr indent="0" lvl="0" marL="0" rtl="0" algn="l"><a:spcBef><a:spcPts val="0"/></a:spcBef><a:spcAft><a:spcPts val="0"/></a:spcAft><a:buNone/></a:pPr><a:r><a:t></a:t></a:r><a:endParaRPr/></a:p></p:txBody></p:sp><p:sp><p:nvSpPr><p:cNvPr id="154" name="Google Shape;154;p7"/><p:cNvSpPr/><p:nvPr/></p:nvSpPr><p:spPr><a:xfrm><a:off x="0" y="4272855"/><a:ext cx="9144000" cy="884039"/></a:xfrm><a:prstGeom prst="rect"><a:avLst/></a:prstGeom><a:noFill/><a:ln><a:noFill/></a:ln></p:spPr><p:txBody><a:bodyPr anchorCtr="0" anchor="t" bIns="510275" lIns="510275" spcFirstLastPara="1" rIns="510275" wrap="square" tIns="340225"><a:spAutoFit/></a:bodyPr><a:lstStyle/><a:p><a:pPr indent="0" lvl="0" marL="0" marR="0" rtl="0" algn="ctr"><a:lnSpc><a:spcPct val="131894"/></a:lnSpc><a:spcBef><a:spcPts val="0"/></a:spcBef><a:spcAft><a:spcPts val="0"/></a:spcAft><a:buClr><a:srgbClr val="334155"/></a:buClr><a:buSzPts val="834"/><a:buFont typeface="Poppins"/><a:buNone/></a:pPr><a:r><a:rPr lang="en-US" sz="1134"><a:solidFill><a:srgbClr val="334155"/></a:solidFill><a:latin typeface="Poppins"/><a:ea typeface="Poppins"/><a:cs typeface="Poppins"/><a:sym typeface="Poppins"/></a:rPr><a:t>We are grateful for the continued support of our partners in building Armenia's AI ecosystem.
+
+Armenia Fund: speaker travel & accommodation for 2025. Nebius: compute infrastructure partner. AI9 & AUA: venue partners. Arcs AI & ASOF: facilitated Armenia Fund and Summer School collaboration. Picsart: travel & speaker accommodation for 2024. Profound Academy: platform for entrance exam.
+
+Collaborations: Martha Hovhannesian—Legal aspects of LLMs (post-school talk). Perouz Taslakian—AI Agents lecture at Yandex Hall. Picsart—office tour for participants.
+
+Armenia Fund: speaker travel & accommodation for 2025. Nebius: compute infrastructure partner. AI9 & AUA: venue partners. Arcs AI & ASOF: facilitated Armenia Fund and Summer School collaboration. Picsart: travel & speaker accommodation for 2024. Profound Academy: platform for entrance exam.</a:t></a:r><a:endParaRPr sz="1134"><a:solidFill><a:schemeClr val="dk1"/></a:solidFill><a:latin typeface="Calibri"/><a:ea typeface="Calibri"/><a:cs typeface="Calibri"/><a:sym typeface="Calibri"/></a:endParaRPr></a:p></p:txBody></p:sp><p:sp><p:nvSpPr><p:cNvPr id="155" name="Google Shape;155;p7"/><p:cNvSpPr/><p:nvPr/></p:nvSpPr><p:spPr><a:xfrm><a:off x="571500" y="1640384"/><a:ext cx="1571625" cy="857250"/></a:xfrm><a:prstGeom prst="rect"><a:avLst/></a:prstGeom><a:solidFill><a:srgbClr val="F8FAFC"/></a:solidFill><a:ln><a:noFill/></a:ln></p:spPr><p:txBody><a:bodyPr anchorCtr="0" anchor="ctr" bIns="91425" lIns="91425" spcFirstLastPara="1" rIns="91425" wrap="square" tIns="91425"><a:noAutofit/></a:bodyPr><a:lstStyle/><a:p><a:pPr indent="0" lvl="0" marL="0" rtl="0" algn="l"><a:spcBef><a:spcPts val="0"/></a:spcBef><a:spcAft><a:spcPts val="0"/></a:spcAft><a:buNone/></a:pPr><a:r><a:t></a:t></a:r><a:endParaRPr/></a:p></p:txBody></p:sp><p:sp><p:nvSpPr><p:cNvPr id="156" name="Google Shape;156;p7"/><p:cNvSpPr/><p:nvPr/></p:nvSpPr><p:spPr><a:xfrm><a:off x="571500" y="1640384"/><a:ext cx="1571625" cy="28575"/></a:xfrm><a:prstGeom prst="rect"><a:avLst/></a:prstGeom><a:solidFill><a:srgbClr val="6B21A8"/></a:solidFill><a:ln><a:noFill/></a:ln></p:spPr><p:txBody><a:bodyPr anchorCtr="0" anchor="ctr" bIns="91425" lIns="91425" spcFirstLastPara="1" rIns="91425" wrap="square" tIns="91425"><a:noAutofit/></a:bodyPr><a:lstStyle/><a:p><a:pPr indent="0" lvl="0" marL="0" rtl="0" algn="l"><a:spcBef><a:spcPts val="0"/></a:spcBef><a:spcAft><a:spcPts val="0"/></a:spcAft><a:buNone/></a:pPr><a:r><a:t></a:t></a:r><a:endParaRPr/></a:p></p:txBody></p:sp><p:sp><p:nvSpPr><p:cNvPr id="157" name="Google Shape;157;p7"/><p:cNvSpPr/><p:nvPr/></p:nvSpPr><p:spPr><a:xfrm><a:off x="4857750" y="1640384"/><a:ext cx="1571625" cy="857250"/></a:xfrm><a:prstGeom prst="rect"><a:avLst/></a:prstGeom><a:solidFill><a:srgbClr val="F8FAFC"/></a:solidFill><a:ln><a:noFill/></a:ln></p:spPr><p:txBody><a:bodyPr anchorCtr="0" anchor="ctr" bIns="91425" lIns="91425" spcFirstLastPara="1" rIns="91425" wrap="square" tIns="91425"><a:noAutofit/></a:bodyPr><a:lstStyle/><a:p><a:pPr indent="0" lvl="0" marL="0" rtl="0" algn="l"><a:spcBef><a:spcPts val="0"/></a:spcBef><a:spcAft><a:spcPts val="0"/></a:spcAft><a:buNone/></a:pPr><a:r><a:t></a:t></a:r><a:endParaRPr/></a:p></p:txBody></p:sp><p:sp><p:nvSpPr><p:cNvPr id="158" name="Google Shape;158;p7"/><p:cNvSpPr/><p:nvPr/></p:nvSpPr><p:spPr><a:xfrm><a:off x="4857750" y="1640384"/><a:ext cx="1571625" cy="28575"/></a:xfrm><a:prstGeom prst="rect"><a:avLst/></a:prstGeom><a:solidFill><a:srgbClr val="6B21A8"/></a:solidFill><a:ln><a:noFill/></a:ln></p:spPr><p:txBody><a:bodyPr anchorCtr="0" anchor="ctr" bIns="91425" lIns="91425" spcFirstLastPara="1" rIns="91425" wrap="square" tIns="91425"><a:noAutofit/></a:bodyPr><a:lstStyle/><a:p><a:pPr indent="0" lvl="0" marL="0" rtl="0" algn="l"><a:spcBef><a:spcPts val="0"/></a:spcBef><a:spcAft><a:spcPts val="0"/></a:spcAft><a:buNone/></a:pPr><a:r><a:t></a:t></a:r><a:endParaRPr/></a:p></p:txBody></p:sp><p:sp><p:nvSpPr><p:cNvPr id="159" name="Google Shape;159;p7"/><p:cNvSpPr/><p:nvPr/></p:nvSpPr><p:spPr><a:xfrm><a:off x="7000875" y="1640384"/><a:ext cx="1571625" cy="857250"/></a:xfrm><a:prstGeom prst="rect"><a:avLst/></a:prstGeom><a:solidFill><a:srgbClr val="F8FAFC"/></a:solidFill><a:ln><a:noFill/></a:ln></p:spPr><p:txBody><a:bodyPr anchorCtr="0" anchor="ctr" bIns="91425" lIns="91425" spcFirstLastPara="1" rIns="91425" wrap="square" tIns="91425"><a:noAutofit/></a:bodyPr><a:lstStyle/><a:p><a:pPr indent="0" lvl="0" marL="0" rtl="0" algn="l"><a:spcBef><a:spcPts val="0"/></a:spcBef><a:spcAft><a:spcPts val="0"/></a:spcAft><a:buNone/></a:pPr><a:r><a:t></a:t></a:r><a:endParaRPr/></a:p></p:txBody></p:sp><p:sp><p:nvSpPr><p:cNvPr id="160" name="Google Shape;160;p7"/><p:cNvSpPr/><p:nvPr/></p:nvSpPr><p:spPr><a:xfrm><a:off x="7000875" y="1640384"/><a:ext cx="1571625" cy="28575"/></a:xfrm><a:prstGeom prst="rect"><a:avLst/></a:prstGeom><a:solidFill><a:srgbClr val="6B21A8"/></a:solidFill><a:ln><a:noFill/></a:ln></p:spPr><p:txBody><a:bodyPr anchorCtr="0" anchor="ctr" bIns="91425" lIns="91425" spcFirstLastPara="1" rIns="91425" wrap="square" tIns="91425"><a:noAutofit/></a:bodyPr><a:lstStyle/><a:p><a:pPr indent="0" lvl="0" marL="0" rtl="0" algn="l"><a:spcBef><a:spcPts val="0"/></a:spcBef><a:spcAft><a:spcPts val="0"/></a:spcAft><a:buNone/></a:pPr><a:r><a:t></a:t></a:r><a:endParaRPr/></a:p></p:txBody></p:sp><p:sp><p:nvSpPr><p:cNvPr id="161" name="Google Shape;161;p7"/><p:cNvSpPr/><p:nvPr/></p:nvSpPr><p:spPr><a:xfrm><a:off x="2714625" y="3007965"/><a:ext cx="1571625" cy="857250"/></a:xfrm><a:prstGeom prst="rect"><a:avLst/></a:prstGeom><a:solidFill><a:srgbClr val="F8FAFC"/></a:solidFill><a:ln><a:noFill/></a:ln></p:spPr><p:txBody><a:bodyPr anchorCtr="0" anchor="ctr" bIns="91425" lIns="91425" spcFirstLastPara="1" rIns="91425" wrap="square" tIns="91425"><a:noAutofit/></a:bodyPr><a:lstStyle/><a:p><a:pPr indent="0" lvl="0" marL="0" rtl="0" algn="l"><a:spcBef><a:spcPts val="0"/></a:spcBef><a:spcAft><a:spcPts val="0"/></a:spcAft><a:buNone/></a:pPr><a:r><a:t></a:t></a:r><a:endParaRPr/></a:p></p:txBody></p:sp><p:sp><p:nvSpPr><p:cNvPr id="162" name="Google Shape;162;p7"/><p:cNvSpPr/><p:nvPr/></p:nvSpPr><p:spPr><a:xfrm><a:off x="2714625" y="3007965"/><a:ext cx="1571625" cy="28575"/></a:xfrm><a:prstGeom prst="rect"><a:avLst/></a:prstGeom><a:solidFill><a:srgbClr val="6B21A8"/></a:solidFill><a:ln><a:noFill/></a:ln></p:spPr><p:txBody><a:bodyPr anchorCtr="0" anchor="ctr" bIns="91425" lIns="91425" spcFirstLastPara="1" rIns="91425" wrap="square" tIns="91425"><a:noAutofit/></a:bodyPr><a:lstStyle/><a:p><a:pPr indent="0" lvl="0" marL="0" rtl="0" algn="l"><a:spcBef><a:spcPts val="0"/></a:spcBef><a:spcAft><a:spcPts val="0"/></a:spcAft><a:buNone/></a:pPr><a:r><a:t></a:t></a:r><a:endParaRPr/></a:p></p:txBody></p:sp><p:sp><p:nvSpPr><p:cNvPr id="163" name="Google Shape;163;p7"/><p:cNvSpPr/><p:nvPr/></p:nvSpPr><p:spPr><a:xfrm><a:off x="571500" y="3005286"/><a:ext cx="1571625" cy="857250"/></a:xfrm><a:prstGeom prst="rect"><a:avLst/></a:prstGeom><a:solidFill><a:srgbClr val="F8FAFC"/></a:solidFill><a:ln><a:noFill/></a:ln></p:spPr><p:txBody><a:bodyPr anchorCtr="0" anchor="ctr" bIns="91425" lIns="91425" spcFirstLastPara="1" rIns="91425" wrap="square" tIns="91425"><a:noAutofit/></a:bodyPr><a:lstStyle/><a:p><a:pPr indent="0" lvl="0" marL="0" rtl="0" algn="l"><a:spcBef><a:spcPts val="0"/></a:spcBef><a:spcAft><a:spcPts val="0"/></a:spcAft><a:buNone/></a:pPr><a:r><a:t></a:t></a:r><a:endParaRPr/></a:p></p:txBody></p:sp><p:sp><p:nvSpPr><p:cNvPr id="164" name="Google Shape;164;p7"/><p:cNvSpPr/><p:nvPr/></p:nvSpPr><p:spPr><a:xfrm><a:off x="571500" y="3005286"/><a:ext cx="1571625" cy="28575"/></a:xfrm><a:prstGeom prst="rect"><a:avLst/></a:prstGeom><a:solidFill><a:srgbClr val="6B21A8"/></a:solidFill><a:ln><a:noFill/></a:ln></p:spPr><p:txBody><a:bodyPr anchorCtr="0" anchor="ctr" bIns="91425" lIns="91425" spcFirstLastPara="1" rIns="91425" wrap="square" tIns="91425"><a:noAutofit/></a:bodyPr><a:lstStyle/><a:p><a:pPr indent="0" lvl="0" marL="0" rtl="0" algn="l"><a:spcBef><a:spcPts val="0"/></a:spcBef><a:spcAft><a:spcPts val="0"/></a:spcAft><a:buNone/></a:pPr><a:r><a:t></a:t></a:r><a:endParaRPr/></a:p></p:txBody></p:sp><p:sp><p:nvSpPr><p:cNvPr id="165" name="Google Shape;165;p7"/><p:cNvSpPr/><p:nvPr/></p:nvSpPr><p:spPr><a:xfrm><a:off x="4857750" y="3005286"/><a:ext cx="1571625" cy="857250"/></a:xfrm><a:prstGeom prst="rect"><a:avLst/></a:prstGeom><a:solidFill><a:srgbClr val="F8FAFC"/></a:solidFill><a:ln><a:noFill/></a:ln></p:spPr><p:txBody><a:bodyPr anchorCtr="0" anchor="ctr" bIns="91425" lIns="91425" spcFirstLastPara="1" rIns="91425" wrap="square" tIns="91425"><a:noAutofit/></a:bodyPr><a:lstStyle/><a:p><a:pPr indent="0" lvl="0" marL="0" rtl="0" algn="l"><a:spcBef><a:spcPts val="0"/></a:spcBef><a:spcAft><a:spcPts val="0"/></a:spcAft><a:buNone/></a:pPr><a:r><a:t></a:t></a:r><a:endParaRPr/></a:p></p:txBody></p:sp><p:sp><p:nvSpPr><p:cNvPr id="166" name="Google Shape;166;p7"/><p:cNvSpPr/><p:nvPr/></p:nvSpPr><p:spPr><a:xfrm><a:off x="4857750" y="3005286"/><a:ext cx="1571625" cy="28575"/></a:xfrm><a:prstGeom prst="rect"><a:avLst/></a:prstGeom><a:solidFill><a:srgbClr val="6B21A8"/></a:solidFill><a:ln><a:noFill/></a:ln></p:spPr><p:txBody><a:bodyPr anchorCtr="0" anchor="ctr" bIns="91425" lIns="91425" spcFirstLastPara="1" rIns="91425" wrap="square" tIns="91425"><a:noAutofit/></a:bodyPr><a:lstStyle/><a:p><a:pPr indent="0" lvl="0" marL="0" rtl="0" algn="l"><a:spcBef><a:spcPts val="0"/></a:spcBef><a:spcAft><a:spcPts val="0"/></a:spcAft><a:buNone/></a:pPr><a:r><a:t></a:t></a:r><a:endParaRPr/></a:p></p:txBody></p:sp><p:sp><p:nvSpPr><p:cNvPr id="167" name="Google Shape;167;p7"/><p:cNvSpPr/><p:nvPr/></p:nvSpPr><p:spPr><a:xfrm><a:off x="7000875" y="3005286"/><a:ext cx="1571625" cy="857250"/></a:xfrm><a:prstGeom prst="rect"><a:avLst/></a:prstGeom><a:solidFill><a:srgbClr val="F8FAFC"/></a:solidFill><a:ln><a:noFill/></a:ln></p:spPr><p:txBody><a:bodyPr anchorCtr="0" anchor="ctr" bIns="91425" lIns="91425" spcFirstLastPara="1" rIns="91425" wrap="square" tIns="91425"><a:noAutofit/></a:bodyPr><a:lstStyle/><a:p><a:pPr indent="0" lvl="0" marL="0" rtl="0" algn="l"><a:spcBef><a:spcPts val="0"/></a:spcBef><a:spcAft><a:spcPts val="0"/></a:spcAft><a:buNone/></a:pPr><a:r><a:t></a:t></a:r><a:endParaRPr/></a:p></p:txBody></p:sp><p:sp><p:nvSpPr><p:cNvPr id="168" name="Google Shape;168;p7"/><p:cNvSpPr/><p:nvPr/></p:nvSpPr><p:spPr><a:xfrm><a:off x="7000875" y="3005286"/><a:ext cx="1571625" cy="28575"/></a:xfrm><a:prstGeom prst="rect"><a:avLst/></a:prstGeom><a:solidFill><a:srgbClr val="6B21A8"/></a:solidFill><a:ln><a:noFill/></a:ln></p:spPr><p:txBody><a:bodyPr anchorCtr="0" anchor="ctr" bIns="91425" lIns="91425" spcFirstLastPara="1" rIns="91425" wrap="square" tIns="91425"><a:noAutofit/></a:bodyPr><a:lstStyle/><a:p><a:pPr indent="0" lvl="0" marL="0" rtl="0" algn="l"><a:spcBef><a:spcPts val="0"/></a:spcBef><a:spcAft><a:spcPts val="0"/></a:spcAft><a:buNone/></a:pPr><a:r><a:t></a:t></a:r><a:endParaRPr/></a:p></p:txBody></p:sp><p:pic><p:nvPicPr><p:cNvPr id="169" name="Google Shape;169;p7"/><p:cNvPicPr preferRelativeResize="0"/><p:nvPr/></p:nvPicPr><p:blipFill rotWithShape="1"><a:blip r:embed="rId4"><a:alphaModFix/></a:blip><a:srcRect b="0" l="0" r="0" t="0"/><a:stretch/></p:blipFill><p:spPr><a:xfrm><a:off x="734511" y="3307333"/><a:ext cx="1206387" cy="281731"/></a:xfrm><a:prstGeom prst="rect"><a:avLst/></a:prstGeom><a:noFill/><a:ln><a:noFill/></a:ln></p:spPr></p:pic><p:pic><p:nvPicPr><p:cNvPr id="170" name="Google Shape;170;p7"/><p:cNvPicPr preferRelativeResize="0"/><p:nvPr/></p:nvPicPr><p:blipFill rotWithShape="1"><a:blip r:embed="rId5"><a:alphaModFix/></a:blip><a:srcRect b="0" l="0" r="0" t="0"/><a:stretch/></p:blipFill><p:spPr><a:xfrm><a:off x="7341942" y="3239247"/><a:ext cx="889489" cy="417902"/></a:xfrm><a:prstGeom prst="rect"><a:avLst/></a:prstGeom><a:noFill/><a:ln><a:noFill/></a:ln></p:spPr></p:pic><p:pic><p:nvPicPr><p:cNvPr id="171" name="Google Shape;171;p7"/><p:cNvPicPr preferRelativeResize="0"/><p:nvPr/></p:nvPicPr><p:blipFill rotWithShape="1"><a:blip r:embed="rId6"><a:alphaModFix/></a:blip><a:srcRect b="0" l="0" r="0" t="0"/><a:stretch/></p:blipFill><p:spPr><a:xfrm><a:off x="2854892" y="3339172"/><a:ext cx="1291090" cy="194837"/></a:xfrm><a:prstGeom prst="rect"><a:avLst/></a:prstGeom><a:noFill/><a:ln><a:noFill/></a:ln></p:spPr></p:pic><p:pic><p:nvPicPr><p:cNvPr id="172" name="Google Shape;172;p7"/><p:cNvPicPr preferRelativeResize="0"/><p:nvPr/></p:nvPicPr><p:blipFill rotWithShape="1"><a:blip r:embed="rId7"><a:alphaModFix/></a:blip><a:srcRect b="0" l="0" r="0" t="0"/><a:stretch/></p:blipFill><p:spPr><a:xfrm><a:off x="895683" y="1613891"/><a:ext cx="878384" cy="878384"/></a:xfrm><a:prstGeom prst="rect"><a:avLst/></a:prstGeom><a:noFill/><a:ln><a:noFill/></a:ln></p:spPr></p:pic><p:pic><p:nvPicPr><p:cNvPr id="173" name="Google Shape;173;p7"/><p:cNvPicPr preferRelativeResize="0"/><p:nvPr/></p:nvPicPr><p:blipFill rotWithShape="1"><a:blip r:embed="rId8"><a:alphaModFix/></a:blip><a:srcRect b="0" l="0" r="0" t="0"/><a:stretch/></p:blipFill><p:spPr><a:xfrm><a:off x="4947840" y="1893060"/><a:ext cx="1391445" cy="380473"/></a:xfrm><a:prstGeom prst="rect"><a:avLst/></a:prstGeom><a:noFill/><a:ln><a:noFill/></a:ln></p:spPr></p:pic><p:pic><p:nvPicPr><p:cNvPr id="174" name="Google Shape;174;p7"/><p:cNvPicPr preferRelativeResize="0"/><p:nvPr/></p:nvPicPr><p:blipFill rotWithShape="1"><a:blip r:embed="rId9"><a:alphaModFix/></a:blip><a:srcRect b="0" l="0" r="0" t="0"/><a:stretch/></p:blipFill><p:spPr><a:xfrm><a:off x="7435621" y="1717944"/><a:ext cx="702129" cy="702129"/></a:xfrm><a:prstGeom prst="rect"><a:avLst/></a:prstGeom><a:noFill/><a:ln><a:noFill/></a:ln></p:spPr></p:pic><p:pic><p:nvPicPr><p:cNvPr id="175" name="Google Shape;175;p7"/><p:cNvPicPr preferRelativeResize="0"/><p:nvPr/></p:nvPicPr><p:blipFill rotWithShape="1"><a:blip r:embed="rId10"><a:alphaModFix/></a:blip><a:srcRect b="0" l="0" r="0" t="0"/><a:stretch/></p:blipFill><p:spPr><a:xfrm><a:off x="5307805" y="3111771"/><a:ext cx="671514" cy="671514"/></a:xfrm><a:prstGeom prst="rect"><a:avLst/></a:prstGeom><a:noFill/><a:ln><a:noFill/></a:ln></p:spPr></p:pic><p:pic><p:nvPicPr><p:cNvPr id="176" name="Google Shape;176;p7" title="67d25f39a9af6b056066b8ae_ARCS-ai logo-p-800.png"/><p:cNvPicPr preferRelativeResize="0"/><p:nvPr/></p:nvPicPr><p:blipFill><a:blip r:embed="rId11"><a:alphaModFix/></a:blip><a:stretch><a:fillRect/></a:stretch></p:blipFill><p:spPr><a:xfrm><a:off x="3134350" y="1717200"/><a:ext cx="732176" cy="732176"/></a:xfrm><a:prstGeom prst="rect"><a:avLst/></a:prstGeom><a:solidFill><a:srgbClr val="F8FAFC"/></a:solidFill><a:ln><a:noFill/></a:ln></p:spPr></p:pic></p:spTree></p:cSld><p:clrMapOvr><a:masterClrMapping/></p:clrMapOvr></p:sld>
 </file>
 
 <file path=ppt/slides/slide8.xml><?xml version="1.0" encoding="utf-8"?>
@@ -13394,693 +12315,12 @@
 </p:sld>
 </file>
 
-<file path=ppt/slides/slide9.xml><?xml version="1.0" encoding="utf-8"?>
-<p:sld xmlns:a="http://schemas.openxmlformats.org/drawingml/2006/main" xmlns:r="http://schemas.openxmlformats.org/officeDocument/2006/relationships" xmlns:mc="http://schemas.openxmlformats.org/markup-compatibility/2006" xmlns:mv="urn:schemas-microsoft-com:mac:vml" xmlns:p="http://schemas.openxmlformats.org/presentationml/2006/main" xmlns:c="http://schemas.openxmlformats.org/drawingml/2006/chart" xmlns:dgm="http://schemas.openxmlformats.org/drawingml/2006/diagram" xmlns:o="urn:schemas-microsoft-com:office:office" xmlns:v="urn:schemas-microsoft-com:vml" xmlns:pvml="urn:schemas-microsoft-com:office:powerpoint" xmlns:com="http://schemas.openxmlformats.org/drawingml/2006/compatibility" xmlns:p14="http://schemas.microsoft.com/office/powerpoint/2010/main" xmlns:p15="http://schemas.microsoft.com/office/powerpoint/2012/main" xmlns:ahyp="http://schemas.microsoft.com/office/drawing/2018/hyperlinkcolor" show="0">
-  <p:cSld>
-    <p:spTree>
-      <p:nvGrpSpPr>
-        <p:cNvPr id="219" name="Shape 219"/>
-        <p:cNvGrpSpPr/>
-        <p:nvPr/>
-      </p:nvGrpSpPr>
-      <p:grpSpPr>
-        <a:xfrm>
-          <a:off x="0" y="0"/>
-          <a:ext cx="0" cy="0"/>
-          <a:chOff x="0" y="0"/>
-          <a:chExt cx="0" cy="0"/>
-        </a:xfrm>
-      </p:grpSpPr>
-      <p:pic>
-        <p:nvPicPr>
-          <p:cNvPr descr="preencoded.png" id="220" name="Google Shape;220;g395e0c14fd2_1_9"/>
-          <p:cNvPicPr preferRelativeResize="0"/>
-          <p:nvPr/>
-        </p:nvPicPr>
-        <p:blipFill rotWithShape="1">
-          <a:blip r:embed="rId3">
-            <a:alphaModFix/>
-          </a:blip>
-          <a:srcRect b="0" l="0" r="0" t="0"/>
-          <a:stretch/>
-        </p:blipFill>
-        <p:spPr>
-          <a:xfrm>
-            <a:off x="0" y="2"/>
-            <a:ext cx="9144000" cy="5143500"/>
-          </a:xfrm>
-          <a:prstGeom prst="rect">
-            <a:avLst/>
-          </a:prstGeom>
-          <a:noFill/>
-          <a:ln>
-            <a:noFill/>
-          </a:ln>
-        </p:spPr>
-      </p:pic>
-      <p:sp>
-        <p:nvSpPr>
-          <p:cNvPr id="221" name="Google Shape;221;g395e0c14fd2_1_9"/>
-          <p:cNvSpPr txBox="1"/>
-          <p:nvPr/>
-        </p:nvSpPr>
-        <p:spPr>
-          <a:xfrm>
-            <a:off x="427450" y="374225"/>
-            <a:ext cx="8583900" cy="431400"/>
-          </a:xfrm>
-          <a:prstGeom prst="rect">
-            <a:avLst/>
-          </a:prstGeom>
-          <a:noFill/>
-          <a:ln>
-            <a:noFill/>
-          </a:ln>
-        </p:spPr>
-        <p:txBody>
-          <a:bodyPr anchorCtr="0" anchor="t" bIns="91425" lIns="91425" spcFirstLastPara="1" rIns="91425" wrap="square" tIns="91425">
-            <a:spAutoFit/>
-          </a:bodyPr>
-          <a:lstStyle/>
-          <a:p>
-            <a:pPr indent="0" lvl="0" marL="0" rtl="0" algn="l">
-              <a:lnSpc>
-                <a:spcPct val="115000"/>
-              </a:lnSpc>
-              <a:spcBef>
-                <a:spcPts val="0"/>
-              </a:spcBef>
-              <a:spcAft>
-                <a:spcPts val="0"/>
-              </a:spcAft>
-              <a:buNone/>
-            </a:pPr>
-            <a:r>
-              <a:rPr b="1" lang="en-US" sz="1602">
-                <a:solidFill>
-                  <a:srgbClr val="0A192F"/>
-                </a:solidFill>
-                <a:latin typeface="Poppins"/>
-                <a:ea typeface="Poppins"/>
-                <a:cs typeface="Poppins"/>
-                <a:sym typeface="Poppins"/>
-              </a:rPr>
-              <a:t>NEEDED BUDGET: 15,000 USD</a:t>
-            </a:r>
-            <a:endParaRPr b="1" sz="1602">
-              <a:solidFill>
-                <a:srgbClr val="0A192F"/>
-              </a:solidFill>
-              <a:latin typeface="Poppins"/>
-              <a:ea typeface="Poppins"/>
-              <a:cs typeface="Poppins"/>
-              <a:sym typeface="Poppins"/>
-            </a:endParaRPr>
-          </a:p>
-        </p:txBody>
-      </p:sp>
-      <p:sp>
-        <p:nvSpPr>
-          <p:cNvPr id="222" name="Google Shape;222;g395e0c14fd2_1_9"/>
-          <p:cNvSpPr txBox="1"/>
-          <p:nvPr/>
-        </p:nvSpPr>
-        <p:spPr>
-          <a:xfrm>
-            <a:off x="427450" y="1304018"/>
-            <a:ext cx="3000000" cy="400200"/>
-          </a:xfrm>
-          <a:prstGeom prst="rect">
-            <a:avLst/>
-          </a:prstGeom>
-          <a:noFill/>
-          <a:ln>
-            <a:noFill/>
-          </a:ln>
-        </p:spPr>
-        <p:txBody>
-          <a:bodyPr anchorCtr="0" anchor="t" bIns="91425" lIns="91425" spcFirstLastPara="1" rIns="91425" wrap="square" tIns="91425">
-            <a:spAutoFit/>
-          </a:bodyPr>
-          <a:lstStyle/>
-          <a:p>
-            <a:pPr indent="0" lvl="0" marL="0" rtl="0" algn="l">
-              <a:lnSpc>
-                <a:spcPct val="115000"/>
-              </a:lnSpc>
-              <a:spcBef>
-                <a:spcPts val="0"/>
-              </a:spcBef>
-              <a:spcAft>
-                <a:spcPts val="0"/>
-              </a:spcAft>
-              <a:buNone/>
-            </a:pPr>
-            <a:r>
-              <a:rPr b="1" lang="en-US">
-                <a:solidFill>
-                  <a:srgbClr val="6B21A8"/>
-                </a:solidFill>
-                <a:latin typeface="Poppins"/>
-                <a:ea typeface="Poppins"/>
-                <a:cs typeface="Poppins"/>
-                <a:sym typeface="Poppins"/>
-              </a:rPr>
-              <a:t>RESEARCHER TRAVEL</a:t>
-            </a:r>
-            <a:endParaRPr b="1">
-              <a:solidFill>
-                <a:srgbClr val="6B21A8"/>
-              </a:solidFill>
-              <a:latin typeface="Poppins"/>
-              <a:ea typeface="Poppins"/>
-              <a:cs typeface="Poppins"/>
-              <a:sym typeface="Poppins"/>
-            </a:endParaRPr>
-          </a:p>
-        </p:txBody>
-      </p:sp>
-      <p:sp>
-        <p:nvSpPr>
-          <p:cNvPr id="223" name="Google Shape;223;g395e0c14fd2_1_9"/>
-          <p:cNvSpPr txBox="1"/>
-          <p:nvPr/>
-        </p:nvSpPr>
-        <p:spPr>
-          <a:xfrm>
-            <a:off x="4807875" y="1304018"/>
-            <a:ext cx="3000000" cy="400200"/>
-          </a:xfrm>
-          <a:prstGeom prst="rect">
-            <a:avLst/>
-          </a:prstGeom>
-          <a:noFill/>
-          <a:ln>
-            <a:noFill/>
-          </a:ln>
-        </p:spPr>
-        <p:txBody>
-          <a:bodyPr anchorCtr="0" anchor="t" bIns="91425" lIns="91425" spcFirstLastPara="1" rIns="91425" wrap="square" tIns="91425">
-            <a:spAutoFit/>
-          </a:bodyPr>
-          <a:lstStyle/>
-          <a:p>
-            <a:pPr indent="0" lvl="0" marL="0" rtl="0" algn="l">
-              <a:lnSpc>
-                <a:spcPct val="115000"/>
-              </a:lnSpc>
-              <a:spcBef>
-                <a:spcPts val="0"/>
-              </a:spcBef>
-              <a:spcAft>
-                <a:spcPts val="0"/>
-              </a:spcAft>
-              <a:buNone/>
-            </a:pPr>
-            <a:r>
-              <a:rPr b="1" lang="en-US">
-                <a:solidFill>
-                  <a:srgbClr val="6B21A8"/>
-                </a:solidFill>
-                <a:latin typeface="Poppins"/>
-                <a:ea typeface="Poppins"/>
-                <a:cs typeface="Poppins"/>
-                <a:sym typeface="Poppins"/>
-              </a:rPr>
-              <a:t>STUDENT FINANCIAL AID</a:t>
-            </a:r>
-            <a:endParaRPr b="1">
-              <a:solidFill>
-                <a:srgbClr val="6B21A8"/>
-              </a:solidFill>
-              <a:latin typeface="Poppins"/>
-              <a:ea typeface="Poppins"/>
-              <a:cs typeface="Poppins"/>
-              <a:sym typeface="Poppins"/>
-            </a:endParaRPr>
-          </a:p>
-        </p:txBody>
-      </p:sp>
-      <p:sp>
-        <p:nvSpPr>
-          <p:cNvPr id="224" name="Google Shape;224;g395e0c14fd2_1_9"/>
-          <p:cNvSpPr txBox="1"/>
-          <p:nvPr/>
-        </p:nvSpPr>
-        <p:spPr>
-          <a:xfrm>
-            <a:off x="427450" y="1704218"/>
-            <a:ext cx="3597900" cy="1293000"/>
-          </a:xfrm>
-          <a:prstGeom prst="rect">
-            <a:avLst/>
-          </a:prstGeom>
-          <a:noFill/>
-          <a:ln>
-            <a:noFill/>
-          </a:ln>
-        </p:spPr>
-        <p:txBody>
-          <a:bodyPr anchorCtr="0" anchor="t" bIns="91425" lIns="91425" spcFirstLastPara="1" rIns="91425" wrap="square" tIns="91425">
-            <a:spAutoFit/>
-          </a:bodyPr>
-          <a:lstStyle/>
-          <a:p>
-            <a:pPr indent="0" lvl="0" marL="0" rtl="0" algn="l">
-              <a:lnSpc>
-                <a:spcPct val="100000"/>
-              </a:lnSpc>
-              <a:spcBef>
-                <a:spcPts val="0"/>
-              </a:spcBef>
-              <a:spcAft>
-                <a:spcPts val="0"/>
-              </a:spcAft>
-              <a:buNone/>
-            </a:pPr>
-            <a:r>
-              <a:rPr lang="en-US" sz="1200">
-                <a:solidFill>
-                  <a:srgbClr val="334155"/>
-                </a:solidFill>
-                <a:latin typeface="Poppins"/>
-                <a:ea typeface="Poppins"/>
-                <a:cs typeface="Poppins"/>
-                <a:sym typeface="Poppins"/>
-              </a:rPr>
-              <a:t>Covers travel and accommodation for </a:t>
-            </a:r>
-            <a:endParaRPr sz="1200">
-              <a:solidFill>
-                <a:srgbClr val="334155"/>
-              </a:solidFill>
-              <a:latin typeface="Poppins"/>
-              <a:ea typeface="Poppins"/>
-              <a:cs typeface="Poppins"/>
-              <a:sym typeface="Poppins"/>
-            </a:endParaRPr>
-          </a:p>
-          <a:p>
-            <a:pPr indent="0" lvl="0" marL="0" rtl="0" algn="l">
-              <a:lnSpc>
-                <a:spcPct val="100000"/>
-              </a:lnSpc>
-              <a:spcBef>
-                <a:spcPts val="0"/>
-              </a:spcBef>
-              <a:spcAft>
-                <a:spcPts val="0"/>
-              </a:spcAft>
-              <a:buNone/>
-            </a:pPr>
-            <a:r>
-              <a:rPr b="1" lang="en-US" sz="1200">
-                <a:solidFill>
-                  <a:srgbClr val="334155"/>
-                </a:solidFill>
-                <a:latin typeface="Poppins"/>
-                <a:ea typeface="Poppins"/>
-                <a:cs typeface="Poppins"/>
-                <a:sym typeface="Poppins"/>
-              </a:rPr>
-              <a:t>5 world-class researchers from the US, Canada, and Europe </a:t>
-            </a:r>
-            <a:r>
-              <a:rPr lang="en-US" sz="1200">
-                <a:solidFill>
-                  <a:srgbClr val="334155"/>
-                </a:solidFill>
-                <a:latin typeface="Poppins"/>
-                <a:ea typeface="Poppins"/>
-                <a:cs typeface="Poppins"/>
-                <a:sym typeface="Poppins"/>
-              </a:rPr>
-              <a:t>to teach at the summer school.</a:t>
-            </a:r>
-            <a:endParaRPr sz="1200">
-              <a:solidFill>
-                <a:srgbClr val="334155"/>
-              </a:solidFill>
-              <a:latin typeface="Poppins"/>
-              <a:ea typeface="Poppins"/>
-              <a:cs typeface="Poppins"/>
-              <a:sym typeface="Poppins"/>
-            </a:endParaRPr>
-          </a:p>
-          <a:p>
-            <a:pPr indent="0" lvl="0" marL="0" rtl="0" algn="l">
-              <a:lnSpc>
-                <a:spcPct val="100000"/>
-              </a:lnSpc>
-              <a:spcBef>
-                <a:spcPts val="0"/>
-              </a:spcBef>
-              <a:spcAft>
-                <a:spcPts val="0"/>
-              </a:spcAft>
-              <a:buNone/>
-            </a:pPr>
-            <a:r>
-              <a:t/>
-            </a:r>
-            <a:endParaRPr sz="1200">
-              <a:solidFill>
-                <a:srgbClr val="334155"/>
-              </a:solidFill>
-              <a:latin typeface="Poppins"/>
-              <a:ea typeface="Poppins"/>
-              <a:cs typeface="Poppins"/>
-              <a:sym typeface="Poppins"/>
-            </a:endParaRPr>
-          </a:p>
-          <a:p>
-            <a:pPr indent="0" lvl="0" marL="0" rtl="0" algn="l">
-              <a:lnSpc>
-                <a:spcPct val="100000"/>
-              </a:lnSpc>
-              <a:spcBef>
-                <a:spcPts val="0"/>
-              </a:spcBef>
-              <a:spcAft>
-                <a:spcPts val="0"/>
-              </a:spcAft>
-              <a:buNone/>
-            </a:pPr>
-            <a:r>
-              <a:rPr i="1" lang="en-US" sz="1200">
-                <a:solidFill>
-                  <a:srgbClr val="334155"/>
-                </a:solidFill>
-                <a:latin typeface="Poppins"/>
-                <a:ea typeface="Poppins"/>
-                <a:cs typeface="Poppins"/>
-                <a:sym typeface="Poppins"/>
-              </a:rPr>
-              <a:t>Covers ticket and accommodation</a:t>
-            </a:r>
-            <a:endParaRPr i="1" sz="1200">
-              <a:solidFill>
-                <a:srgbClr val="334155"/>
-              </a:solidFill>
-              <a:latin typeface="Poppins"/>
-              <a:ea typeface="Poppins"/>
-              <a:cs typeface="Poppins"/>
-              <a:sym typeface="Poppins"/>
-            </a:endParaRPr>
-          </a:p>
-        </p:txBody>
-      </p:sp>
-      <p:sp>
-        <p:nvSpPr>
-          <p:cNvPr id="225" name="Google Shape;225;g395e0c14fd2_1_9"/>
-          <p:cNvSpPr txBox="1"/>
-          <p:nvPr/>
-        </p:nvSpPr>
-        <p:spPr>
-          <a:xfrm>
-            <a:off x="4807875" y="1704218"/>
-            <a:ext cx="3597900" cy="923400"/>
-          </a:xfrm>
-          <a:prstGeom prst="rect">
-            <a:avLst/>
-          </a:prstGeom>
-          <a:noFill/>
-          <a:ln>
-            <a:noFill/>
-          </a:ln>
-        </p:spPr>
-        <p:txBody>
-          <a:bodyPr anchorCtr="0" anchor="t" bIns="91425" lIns="91425" spcFirstLastPara="1" rIns="91425" wrap="square" tIns="91425">
-            <a:spAutoFit/>
-          </a:bodyPr>
-          <a:lstStyle/>
-          <a:p>
-            <a:pPr indent="0" lvl="0" marL="0" rtl="0" algn="l">
-              <a:lnSpc>
-                <a:spcPct val="100000"/>
-              </a:lnSpc>
-              <a:spcBef>
-                <a:spcPts val="0"/>
-              </a:spcBef>
-              <a:spcAft>
-                <a:spcPts val="0"/>
-              </a:spcAft>
-              <a:buNone/>
-            </a:pPr>
-            <a:r>
-              <a:rPr lang="en-US" sz="1200">
-                <a:solidFill>
-                  <a:srgbClr val="334155"/>
-                </a:solidFill>
-                <a:latin typeface="Poppins"/>
-                <a:ea typeface="Poppins"/>
-                <a:cs typeface="Poppins"/>
-                <a:sym typeface="Poppins"/>
-              </a:rPr>
-              <a:t>Providing </a:t>
-            </a:r>
-            <a:r>
-              <a:rPr b="1" lang="en-US" sz="1200">
-                <a:solidFill>
-                  <a:srgbClr val="334155"/>
-                </a:solidFill>
-                <a:latin typeface="Poppins"/>
-                <a:ea typeface="Poppins"/>
-                <a:cs typeface="Poppins"/>
-                <a:sym typeface="Poppins"/>
-              </a:rPr>
-              <a:t>up to 90% financial aid for Armenian University students</a:t>
-            </a:r>
-            <a:r>
-              <a:rPr lang="en-US" sz="1200">
-                <a:solidFill>
-                  <a:srgbClr val="334155"/>
-                </a:solidFill>
-                <a:latin typeface="Poppins"/>
-                <a:ea typeface="Poppins"/>
-                <a:cs typeface="Poppins"/>
-                <a:sym typeface="Poppins"/>
-              </a:rPr>
-              <a:t> to ensure merit-based access to high-quality AI education.</a:t>
-            </a:r>
-            <a:endParaRPr sz="1200">
-              <a:solidFill>
-                <a:srgbClr val="334155"/>
-              </a:solidFill>
-              <a:latin typeface="Poppins"/>
-              <a:ea typeface="Poppins"/>
-              <a:cs typeface="Poppins"/>
-              <a:sym typeface="Poppins"/>
-            </a:endParaRPr>
-          </a:p>
-        </p:txBody>
-      </p:sp>
-      <p:sp>
-        <p:nvSpPr>
-          <p:cNvPr id="226" name="Google Shape;226;g395e0c14fd2_1_9"/>
-          <p:cNvSpPr txBox="1"/>
-          <p:nvPr/>
-        </p:nvSpPr>
-        <p:spPr>
-          <a:xfrm>
-            <a:off x="2494625" y="3016250"/>
-            <a:ext cx="3000000" cy="400200"/>
-          </a:xfrm>
-          <a:prstGeom prst="rect">
-            <a:avLst/>
-          </a:prstGeom>
-          <a:noFill/>
-          <a:ln>
-            <a:noFill/>
-          </a:ln>
-        </p:spPr>
-        <p:txBody>
-          <a:bodyPr anchorCtr="0" anchor="t" bIns="91425" lIns="91425" spcFirstLastPara="1" rIns="91425" wrap="square" tIns="91425">
-            <a:spAutoFit/>
-          </a:bodyPr>
-          <a:lstStyle/>
-          <a:p>
-            <a:pPr indent="0" lvl="0" marL="0" rtl="0" algn="ctr">
-              <a:lnSpc>
-                <a:spcPct val="115000"/>
-              </a:lnSpc>
-              <a:spcBef>
-                <a:spcPts val="0"/>
-              </a:spcBef>
-              <a:spcAft>
-                <a:spcPts val="0"/>
-              </a:spcAft>
-              <a:buNone/>
-            </a:pPr>
-            <a:r>
-              <a:t/>
-            </a:r>
-            <a:endParaRPr i="1">
-              <a:solidFill>
-                <a:srgbClr val="0F172A"/>
-              </a:solidFill>
-            </a:endParaRPr>
-          </a:p>
-        </p:txBody>
-      </p:sp>
-      <p:sp>
-        <p:nvSpPr>
-          <p:cNvPr id="227" name="Google Shape;227;g395e0c14fd2_1_9"/>
-          <p:cNvSpPr/>
-          <p:nvPr/>
-        </p:nvSpPr>
-        <p:spPr>
-          <a:xfrm>
-            <a:off x="575950" y="4301675"/>
-            <a:ext cx="8286900" cy="628800"/>
-          </a:xfrm>
-          <a:prstGeom prst="rect">
-            <a:avLst/>
-          </a:prstGeom>
-          <a:solidFill>
-            <a:srgbClr val="F8FAFC"/>
-          </a:solidFill>
-          <a:ln>
-            <a:noFill/>
-          </a:ln>
-        </p:spPr>
-        <p:txBody>
-          <a:bodyPr anchorCtr="0" anchor="ctr" bIns="91425" lIns="91425" spcFirstLastPara="1" rIns="91425" wrap="square" tIns="91425">
-            <a:noAutofit/>
-          </a:bodyPr>
-          <a:lstStyle/>
-          <a:p>
-            <a:pPr indent="0" lvl="0" marL="0" rtl="0" algn="l">
-              <a:spcBef>
-                <a:spcPts val="0"/>
-              </a:spcBef>
-              <a:spcAft>
-                <a:spcPts val="0"/>
-              </a:spcAft>
-              <a:buNone/>
-            </a:pPr>
-            <a:r>
-              <a:t/>
-            </a:r>
-            <a:endParaRPr/>
-          </a:p>
-        </p:txBody>
-      </p:sp>
-      <p:sp>
-        <p:nvSpPr>
-          <p:cNvPr id="228" name="Google Shape;228;g395e0c14fd2_1_9"/>
-          <p:cNvSpPr/>
-          <p:nvPr/>
-        </p:nvSpPr>
-        <p:spPr>
-          <a:xfrm>
-            <a:off x="575950" y="4301675"/>
-            <a:ext cx="8286900" cy="28500"/>
-          </a:xfrm>
-          <a:prstGeom prst="rect">
-            <a:avLst/>
-          </a:prstGeom>
-          <a:solidFill>
-            <a:srgbClr val="6B21A8"/>
-          </a:solidFill>
-          <a:ln>
-            <a:noFill/>
-          </a:ln>
-        </p:spPr>
-        <p:txBody>
-          <a:bodyPr anchorCtr="0" anchor="ctr" bIns="91425" lIns="91425" spcFirstLastPara="1" rIns="91425" wrap="square" tIns="91425">
-            <a:noAutofit/>
-          </a:bodyPr>
-          <a:lstStyle/>
-          <a:p>
-            <a:pPr indent="0" lvl="0" marL="0" rtl="0" algn="l">
-              <a:spcBef>
-                <a:spcPts val="0"/>
-              </a:spcBef>
-              <a:spcAft>
-                <a:spcPts val="0"/>
-              </a:spcAft>
-              <a:buNone/>
-            </a:pPr>
-            <a:r>
-              <a:t/>
-            </a:r>
-            <a:endParaRPr/>
-          </a:p>
-        </p:txBody>
-      </p:sp>
-      <p:sp>
-        <p:nvSpPr>
-          <p:cNvPr id="229" name="Google Shape;229;g395e0c14fd2_1_9"/>
-          <p:cNvSpPr/>
-          <p:nvPr/>
-        </p:nvSpPr>
-        <p:spPr>
-          <a:xfrm>
-            <a:off x="861700" y="4491646"/>
-            <a:ext cx="7715400" cy="302400"/>
-          </a:xfrm>
-          <a:prstGeom prst="rect">
-            <a:avLst/>
-          </a:prstGeom>
-          <a:noFill/>
-          <a:ln>
-            <a:noFill/>
-          </a:ln>
-        </p:spPr>
-        <p:txBody>
-          <a:bodyPr anchorCtr="0" anchor="t" bIns="0" lIns="0" spcFirstLastPara="1" rIns="0" wrap="square" tIns="0">
-            <a:noAutofit/>
-          </a:bodyPr>
-          <a:lstStyle/>
-          <a:p>
-            <a:pPr indent="0" lvl="0" marL="0" marR="0" rtl="0" algn="ctr">
-              <a:lnSpc>
-                <a:spcPct val="135593"/>
-              </a:lnSpc>
-              <a:spcBef>
-                <a:spcPts val="0"/>
-              </a:spcBef>
-              <a:spcAft>
-                <a:spcPts val="0"/>
-              </a:spcAft>
-              <a:buClr>
-                <a:srgbClr val="0A192F"/>
-              </a:buClr>
-              <a:buSzPts val="885"/>
-              <a:buFont typeface="Poppins"/>
-              <a:buNone/>
-            </a:pPr>
-            <a:r>
-              <a:rPr b="1" lang="en-US" sz="1085">
-                <a:solidFill>
-                  <a:srgbClr val="0A192F"/>
-                </a:solidFill>
-                <a:latin typeface="Poppins"/>
-                <a:ea typeface="Poppins"/>
-                <a:cs typeface="Poppins"/>
-                <a:sym typeface="Poppins"/>
-              </a:rPr>
-              <a:t>Your support directly enables global expertise to empower local talent in Armenia.</a:t>
-            </a:r>
-            <a:endParaRPr b="1" sz="1085">
-              <a:solidFill>
-                <a:srgbClr val="0A192F"/>
-              </a:solidFill>
-              <a:latin typeface="Poppins"/>
-              <a:ea typeface="Poppins"/>
-              <a:cs typeface="Poppins"/>
-              <a:sym typeface="Poppins"/>
-            </a:endParaRPr>
-          </a:p>
-        </p:txBody>
-      </p:sp>
-    </p:spTree>
-  </p:cSld>
-  <p:clrMapOvr>
-    <a:masterClrMapping/>
-  </p:clrMapOvr>
-</p:sld>
+<file path=ppt/slides/slide9.xml><?xml version="1.0" encoding="UTF-8" standalone="yes"?>
+<p:sld xmlns:a="http://schemas.openxmlformats.org/drawingml/2006/main" xmlns:r="http://schemas.openxmlformats.org/officeDocument/2006/relationships" xmlns:mc="http://schemas.openxmlformats.org/markup-compatibility/2006" xmlns:mv="urn:schemas-microsoft-com:mac:vml" xmlns:p="http://schemas.openxmlformats.org/presentationml/2006/main" xmlns:c="http://schemas.openxmlformats.org/drawingml/2006/chart" xmlns:dgm="http://schemas.openxmlformats.org/drawingml/2006/diagram" xmlns:o="urn:schemas-microsoft-com:office:office" xmlns:v="urn:schemas-microsoft-com:vml" xmlns:pvml="urn:schemas-microsoft-com:office:powerpoint" xmlns:com="http://schemas.openxmlformats.org/drawingml/2006/compatibility" xmlns:p14="http://schemas.microsoft.com/office/powerpoint/2010/main" xmlns:p15="http://schemas.microsoft.com/office/powerpoint/2012/main" xmlns:ahyp="http://schemas.microsoft.com/office/drawing/2018/hyperlinkcolor" show="0"><p:cSld><p:spTree><p:nvGrpSpPr><p:cNvPr id="219" name="Shape 219"/><p:cNvGrpSpPr/><p:nvPr/></p:nvGrpSpPr><p:grpSpPr><a:xfrm><a:off x="0" y="0"/><a:ext cx="0" cy="0"/><a:chOff x="0" y="0"/><a:chExt cx="0" cy="0"/></a:xfrm></p:grpSpPr><p:pic><p:nvPicPr><p:cNvPr descr="preencoded.png" id="220" name="Google Shape;220;g395e0c14fd2_1_9"/><p:cNvPicPr preferRelativeResize="0"/><p:nvPr/></p:nvPicPr><p:blipFill rotWithShape="1"><a:blip r:embed="rId3"><a:alphaModFix/></a:blip><a:srcRect b="0" l="0" r="0" t="0"/><a:stretch/></p:blipFill><p:spPr><a:xfrm><a:off x="0" y="2"/><a:ext cx="9144000" cy="5143500"/></a:xfrm><a:prstGeom prst="rect"><a:avLst/></a:prstGeom><a:noFill/><a:ln><a:noFill/></a:ln></p:spPr></p:pic><p:sp><p:nvSpPr><p:cNvPr id="221" name="Google Shape;221;g395e0c14fd2_1_9"/><p:cNvSpPr txBox="1"/><p:nvPr/></p:nvSpPr><p:spPr><a:xfrm><a:off x="427450" y="374225"/><a:ext cx="8583900" cy="431400"/></a:xfrm><a:prstGeom prst="rect"><a:avLst/></a:prstGeom><a:noFill/><a:ln><a:noFill/></a:ln></p:spPr><p:txBody><a:bodyPr anchorCtr="0" anchor="t" bIns="91425" lIns="91425" spcFirstLastPara="1" rIns="91425" wrap="square" tIns="91425"><a:spAutoFit/></a:bodyPr><a:lstStyle/><a:p><a:pPr indent="0" lvl="0" marL="0" rtl="0" algn="l"><a:lnSpc><a:spcPct val="115000"/></a:lnSpc><a:spcBef><a:spcPts val="0"/></a:spcBef><a:spcAft><a:spcPts val="0"/></a:spcAft><a:buNone/></a:pPr><a:r><a:rPr b="1" lang="en-US" sz="1602"><a:solidFill><a:srgbClr val="0A192F"/></a:solidFill><a:latin typeface="Poppins"/><a:ea typeface="Poppins"/><a:cs typeface="Poppins"/><a:sym typeface="Poppins"/></a:rPr><a:t>NEEDED BUDGET: 15,000 USD</a:t></a:r><a:endParaRPr b="1" sz="1602"><a:solidFill><a:srgbClr val="0A192F"/></a:solidFill><a:latin typeface="Poppins"/><a:ea typeface="Poppins"/><a:cs typeface="Poppins"/><a:sym typeface="Poppins"/></a:endParaRPr></a:p></p:txBody></p:sp><p:sp><p:nvSpPr><p:cNvPr id="222" name="Google Shape;222;g395e0c14fd2_1_9"/><p:cNvSpPr txBox="1"/><p:nvPr/></p:nvSpPr><p:spPr><a:xfrm><a:off x="427450" y="1304018"/><a:ext cx="3000000" cy="400200"/></a:xfrm><a:prstGeom prst="rect"><a:avLst/></a:prstGeom><a:noFill/><a:ln><a:noFill/></a:ln></p:spPr><p:txBody><a:bodyPr anchorCtr="0" anchor="t" bIns="91425" lIns="91425" spcFirstLastPara="1" rIns="91425" wrap="square" tIns="91425"><a:spAutoFit/></a:bodyPr><a:lstStyle/><a:p><a:pPr indent="0" lvl="0" marL="0" rtl="0" algn="l"><a:lnSpc><a:spcPct val="115000"/></a:lnSpc><a:spcBef><a:spcPts val="0"/></a:spcBef><a:spcAft><a:spcPts val="0"/></a:spcAft><a:buNone/></a:pPr><a:r><a:rPr b="1" lang="en-US"><a:solidFill><a:srgbClr val="6B21A8"/></a:solidFill><a:latin typeface="Poppins"/><a:ea typeface="Poppins"/><a:cs typeface="Poppins"/><a:sym typeface="Poppins"/></a:rPr><a:t>RESEARCHER TRAVEL</a:t></a:r><a:endParaRPr b="1"><a:solidFill><a:srgbClr val="6B21A8"/></a:solidFill><a:latin typeface="Poppins"/><a:ea typeface="Poppins"/><a:cs typeface="Poppins"/><a:sym typeface="Poppins"/></a:endParaRPr></a:p></p:txBody></p:sp><p:sp><p:nvSpPr><p:cNvPr id="223" name="Google Shape;223;g395e0c14fd2_1_9"/><p:cNvSpPr txBox="1"/><p:nvPr/></p:nvSpPr><p:spPr><a:xfrm><a:off x="4807875" y="1304018"/><a:ext cx="3000000" cy="400200"/></a:xfrm><a:prstGeom prst="rect"><a:avLst/></a:prstGeom><a:noFill/><a:ln><a:noFill/></a:ln></p:spPr><p:txBody><a:bodyPr anchorCtr="0" anchor="t" bIns="91425" lIns="91425" spcFirstLastPara="1" rIns="91425" wrap="square" tIns="91425"><a:spAutoFit/></a:bodyPr><a:lstStyle/><a:p><a:pPr indent="0" lvl="0" marL="0" rtl="0" algn="l"><a:lnSpc><a:spcPct val="115000"/></a:lnSpc><a:spcBef><a:spcPts val="0"/></a:spcBef><a:spcAft><a:spcPts val="0"/></a:spcAft><a:buNone/></a:pPr><a:r><a:rPr b="1" lang="en-US"><a:solidFill><a:srgbClr val="6B21A8"/></a:solidFill><a:latin typeface="Poppins"/><a:ea typeface="Poppins"/><a:cs typeface="Poppins"/><a:sym typeface="Poppins"/></a:rPr><a:t>STUDENT FINANCIAL AID</a:t></a:r><a:endParaRPr b="1"><a:solidFill><a:srgbClr val="6B21A8"/></a:solidFill><a:latin typeface="Poppins"/><a:ea typeface="Poppins"/><a:cs typeface="Poppins"/><a:sym typeface="Poppins"/></a:endParaRPr></a:p></p:txBody></p:sp><p:sp><p:nvSpPr><p:cNvPr id="224" name="Google Shape;224;g395e0c14fd2_1_9"/><p:cNvSpPr txBox="1"/><p:nvPr/></p:nvSpPr><p:spPr><a:xfrm><a:off x="427450" y="1704218"/><a:ext cx="3597900" cy="1293000"/></a:xfrm><a:prstGeom prst="rect"><a:avLst/></a:prstGeom><a:noFill/><a:ln><a:noFill/></a:ln></p:spPr><p:txBody><a:bodyPr anchorCtr="0" anchor="t" bIns="91425" lIns="91425" spcFirstLastPara="1" rIns="91425" wrap="square" tIns="91425"><a:spAutoFit/></a:bodyPr><a:lstStyle/><a:p><a:pPr indent="0" lvl="0" marL="0" rtl="0" algn="l"><a:lnSpc><a:spcPct val="100000"/></a:lnSpc><a:spcBef><a:spcPts val="0"/></a:spcBef><a:spcAft><a:spcPts val="0"/></a:spcAft><a:buNone/></a:pPr><a:r><a:rPr lang="en-US" sz="1200"><a:solidFill><a:srgbClr val="334155"/></a:solidFill><a:latin typeface="Poppins"/><a:ea typeface="Poppins"/><a:cs typeface="Poppins"/><a:sym typeface="Poppins"/></a:rPr><a:t>Covers travel and accommodation for </a:t></a:r><a:endParaRPr sz="1200"><a:solidFill><a:srgbClr val="334155"/></a:solidFill><a:latin typeface="Poppins"/><a:ea typeface="Poppins"/><a:cs typeface="Poppins"/><a:sym typeface="Poppins"/></a:endParaRPr></a:p><a:p><a:pPr indent="0" lvl="0" marL="0" rtl="0" algn="l"><a:lnSpc><a:spcPct val="100000"/></a:lnSpc><a:spcBef><a:spcPts val="0"/></a:spcBef><a:spcAft><a:spcPts val="0"/></a:spcAft><a:buNone/></a:pPr><a:r><a:rPr b="1" lang="en-US" sz="1200"><a:solidFill><a:srgbClr val="334155"/></a:solidFill><a:latin typeface="Poppins"/><a:ea typeface="Poppins"/><a:cs typeface="Poppins"/><a:sym typeface="Poppins"/></a:rPr><a:t>5 world-class researchers from the US, Canada, and Europe </a:t></a:r><a:r><a:rPr lang="en-US" sz="1200"><a:solidFill><a:srgbClr val="334155"/></a:solidFill><a:latin typeface="Poppins"/><a:ea typeface="Poppins"/><a:cs typeface="Poppins"/><a:sym typeface="Poppins"/></a:rPr><a:t>to teach at the summer school.</a:t></a:r><a:endParaRPr sz="1200"><a:solidFill><a:srgbClr val="334155"/></a:solidFill><a:latin typeface="Poppins"/><a:ea typeface="Poppins"/><a:cs typeface="Poppins"/><a:sym typeface="Poppins"/></a:endParaRPr></a:p><a:p><a:pPr indent="0" lvl="0" marL="0" rtl="0" algn="l"><a:lnSpc><a:spcPct val="100000"/></a:lnSpc><a:spcBef><a:spcPts val="0"/></a:spcBef><a:spcAft><a:spcPts val="0"/></a:spcAft><a:buNone/></a:pPr><a:r><a:t></a:t></a:r><a:endParaRPr sz="1200"><a:solidFill><a:srgbClr val="334155"/></a:solidFill><a:latin typeface="Poppins"/><a:ea typeface="Poppins"/><a:cs typeface="Poppins"/><a:sym typeface="Poppins"/></a:endParaRPr></a:p><a:p><a:pPr indent="0" lvl="0" marL="0" rtl="0" algn="l"><a:lnSpc><a:spcPct val="100000"/></a:lnSpc><a:spcBef><a:spcPts val="0"/></a:spcBef><a:spcAft><a:spcPts val="0"/></a:spcAft><a:buNone/></a:pPr><a:r><a:rPr i="1" lang="en-US" sz="1200"><a:solidFill><a:srgbClr val="334155"/></a:solidFill><a:latin typeface="Poppins"/><a:ea typeface="Poppins"/><a:cs typeface="Poppins"/><a:sym typeface="Poppins"/></a:rPr><a:t>Covers ticket and accommodation</a:t></a:r><a:endParaRPr i="1" sz="1200"><a:solidFill><a:srgbClr val="334155"/></a:solidFill><a:latin typeface="Poppins"/><a:ea typeface="Poppins"/><a:cs typeface="Poppins"/><a:sym typeface="Poppins"/></a:endParaRPr></a:p></p:txBody></p:sp><p:sp><p:nvSpPr><p:cNvPr id="225" name="Google Shape;225;g395e0c14fd2_1_9"/><p:cNvSpPr txBox="1"/><p:nvPr/></p:nvSpPr><p:spPr><a:xfrm><a:off x="4807875" y="1704218"/><a:ext cx="3597900" cy="923400"/></a:xfrm><a:prstGeom prst="rect"><a:avLst/></a:prstGeom><a:noFill/><a:ln><a:noFill/></a:ln></p:spPr><p:txBody><a:bodyPr anchorCtr="0" anchor="t" bIns="91425" lIns="91425" spcFirstLastPara="1" rIns="91425" wrap="square" tIns="91425"><a:spAutoFit/></a:bodyPr><a:lstStyle/><a:p><a:pPr indent="0" lvl="0" marL="0" rtl="0" algn="l"><a:lnSpc><a:spcPct val="100000"/></a:lnSpc><a:spcBef><a:spcPts val="0"/></a:spcBef><a:spcAft><a:spcPts val="0"/></a:spcAft><a:buNone/></a:pPr><a:r><a:rPr lang="en-US" sz="1200"><a:solidFill><a:srgbClr val="334155"/></a:solidFill><a:latin typeface="Poppins"/><a:ea typeface="Poppins"/><a:cs typeface="Poppins"/><a:sym typeface="Poppins"/></a:rPr><a:t>Providing </a:t></a:r><a:r><a:rPr b="1" lang="en-US" sz="1200"><a:solidFill><a:srgbClr val="334155"/></a:solidFill><a:latin typeface="Poppins"/><a:ea typeface="Poppins"/><a:cs typeface="Poppins"/><a:sym typeface="Poppins"/></a:rPr><a:t>up to 90% financial aid for Armenian University students</a:t></a:r><a:r><a:rPr lang="en-US" sz="1200"><a:solidFill><a:srgbClr val="334155"/></a:solidFill><a:latin typeface="Poppins"/><a:ea typeface="Poppins"/><a:cs typeface="Poppins"/><a:sym typeface="Poppins"/></a:rPr><a:t> to ensure merit-based access to high-quality AI education.</a:t></a:r><a:endParaRPr sz="1200"><a:solidFill><a:srgbClr val="334155"/></a:solidFill><a:latin typeface="Poppins"/><a:ea typeface="Poppins"/><a:cs typeface="Poppins"/><a:sym typeface="Poppins"/></a:endParaRPr></a:p></p:txBody></p:sp><p:sp><p:nvSpPr><p:cNvPr id="226" name="Google Shape;226;g395e0c14fd2_1_9"/><p:cNvSpPr txBox="1"/><p:nvPr/></p:nvSpPr><p:spPr><a:xfrm><a:off x="2494625" y="3016250"/><a:ext cx="3000000" cy="400200"/></a:xfrm><a:prstGeom prst="rect"><a:avLst/></a:prstGeom><a:noFill/><a:ln><a:noFill/></a:ln></p:spPr><p:txBody><a:bodyPr anchorCtr="0" anchor="t" bIns="91425" lIns="91425" spcFirstLastPara="1" rIns="91425" wrap="square" tIns="91425"><a:spAutoFit/></a:bodyPr><a:lstStyle/><a:p><a:pPr indent="0" lvl="0" marL="0" rtl="0" algn="ctr"><a:lnSpc><a:spcPct val="115000"/></a:lnSpc><a:spcBef><a:spcPts val="0"/></a:spcBef><a:spcAft><a:spcPts val="0"/></a:spcAft><a:buNone/></a:pPr><a:r><a:t></a:t></a:r><a:endParaRPr i="1"><a:solidFill><a:srgbClr val="0F172A"/></a:solidFill></a:endParaRPr></a:p></p:txBody></p:sp><p:sp><p:nvSpPr><p:cNvPr id="227" name="Google Shape;227;g395e0c14fd2_1_9"/><p:cNvSpPr/><p:nvPr/></p:nvSpPr><p:spPr><a:xfrm><a:off x="575950" y="4301675"/><a:ext cx="8286900" cy="628800"/></a:xfrm><a:prstGeom prst="rect"><a:avLst/></a:prstGeom><a:solidFill><a:srgbClr val="F8FAFC"/></a:solidFill><a:ln><a:noFill/></a:ln></p:spPr><p:txBody><a:bodyPr anchorCtr="0" anchor="ctr" bIns="91425" lIns="91425" spcFirstLastPara="1" rIns="91425" wrap="square" tIns="91425"><a:noAutofit/></a:bodyPr><a:lstStyle/><a:p><a:pPr indent="0" lvl="0" marL="0" rtl="0" algn="l"><a:spcBef><a:spcPts val="0"/></a:spcBef><a:spcAft><a:spcPts val="0"/></a:spcAft><a:buNone/></a:pPr><a:r><a:t></a:t></a:r><a:endParaRPr/></a:p></p:txBody></p:sp><p:sp><p:nvSpPr><p:cNvPr id="228" name="Google Shape;228;g395e0c14fd2_1_9"/><p:cNvSpPr/><p:nvPr/></p:nvSpPr><p:spPr><a:xfrm><a:off x="575950" y="4301675"/><a:ext cx="8286900" cy="28500"/></a:xfrm><a:prstGeom prst="rect"><a:avLst/></a:prstGeom><a:solidFill><a:srgbClr val="6B21A8"/></a:solidFill><a:ln><a:noFill/></a:ln></p:spPr><p:txBody><a:bodyPr anchorCtr="0" anchor="ctr" bIns="91425" lIns="91425" spcFirstLastPara="1" rIns="91425" wrap="square" tIns="91425"><a:noAutofit/></a:bodyPr><a:lstStyle/><a:p><a:pPr indent="0" lvl="0" marL="0" rtl="0" algn="l"><a:spcBef><a:spcPts val="0"/></a:spcBef><a:spcAft><a:spcPts val="0"/></a:spcAft><a:buNone/></a:pPr><a:r><a:t></a:t></a:r><a:endParaRPr/></a:p></p:txBody></p:sp><p:sp><p:nvSpPr><p:cNvPr id="229" name="Google Shape;229;g395e0c14fd2_1_9"/><p:cNvSpPr/><p:nvPr/></p:nvSpPr><p:spPr><a:xfrm><a:off x="861700" y="4491646"/><a:ext cx="7715400" cy="302400"/></a:xfrm><a:prstGeom prst="rect"><a:avLst/></a:prstGeom><a:noFill/><a:ln><a:noFill/></a:ln></p:spPr><p:txBody><a:bodyPr anchorCtr="0" anchor="t" bIns="0" lIns="0" spcFirstLastPara="1" rIns="0" wrap="square" tIns="0"><a:noAutofit/></a:bodyPr><a:lstStyle/><a:p><a:pPr indent="0" lvl="0" marL="0" marR="0" rtl="0" algn="ctr"><a:lnSpc><a:spcPct val="135593"/></a:lnSpc><a:spcBef><a:spcPts val="0"/></a:spcBef><a:spcAft><a:spcPts val="0"/></a:spcAft><a:buClr><a:srgbClr val="0A192F"/></a:buClr><a:buSzPts val="885"/><a:buFont typeface="Poppins"/><a:buNone/></a:pPr><a:r><a:rPr b="1" lang="en-US" sz="1085"><a:solidFill><a:srgbClr val="0A192F"/></a:solidFill><a:latin typeface="Poppins"/><a:ea typeface="Poppins"/><a:cs typeface="Poppins"/><a:sym typeface="Poppins"/></a:rPr><a:t>Last year budget: ~15K USD for speaker travel & accommodation in Yerevan; 11K USD for online accommodation, logistics, coffee breaks, networking. Financial aid: 35 students (90%); 42 industry professionals paid 100,000 AMD. 80 GPUs for school (~60K value); 1 GPU per student. Speakers: no honorarium, travel only. Venue: AI9 contribution.
+
+Last year budget: ~15K USD for speaker travel & accommodation in Yerevan; 11K USD for online accommodation, logistics, coffee breaks, networking. Financial aid: 35 students (90%); 42 industry professionals paid 100,000 AMD. 80 GPUs for school (~60K value); 1 GPU per student. Speakers: no honorarium, travel only. Venue: AI9 contribution.
+
+Your support directly enables global expertise to empower local talent in Armenia.</a:t></a:r><a:endParaRPr b="1" sz="1085"><a:solidFill><a:srgbClr val="0A192F"/></a:solidFill><a:latin typeface="Poppins"/><a:ea typeface="Poppins"/><a:cs typeface="Poppins"/><a:sym typeface="Poppins"/></a:endParaRPr></a:p></p:txBody></p:sp></p:spTree></p:cSld><p:clrMapOvr><a:masterClrMapping/></p:clrMapOvr></p:sld>
 </file>
 
 <file path=ppt/theme/theme1.xml><?xml version="1.0" encoding="utf-8"?>

</xml_diff>